<commit_message>
some stuff block 2 lecs
</commit_message>
<xml_diff>
--- a/dapr3_lectures/block2_fa/img_sandbox/efa_output_2627.pptx
+++ b/dapr3_lectures/block2_fa/img_sandbox/efa_output_2627.pptx
@@ -290,7 +290,7 @@
           <a:p>
             <a:fld id="{2E7CC89D-3142-46AB-8DEE-A39EF376CEDE}" type="datetimeFigureOut">
               <a:rPr lang="en-GB" smtClean="0"/>
-              <a:t>03/07/2026</a:t>
+              <a:t>05/08/2026</a:t>
             </a:fld>
             <a:endParaRPr lang="en-GB"/>
           </a:p>
@@ -490,7 +490,7 @@
           <a:p>
             <a:fld id="{2E7CC89D-3142-46AB-8DEE-A39EF376CEDE}" type="datetimeFigureOut">
               <a:rPr lang="en-GB" smtClean="0"/>
-              <a:t>03/07/2026</a:t>
+              <a:t>05/08/2026</a:t>
             </a:fld>
             <a:endParaRPr lang="en-GB"/>
           </a:p>
@@ -700,7 +700,7 @@
           <a:p>
             <a:fld id="{2E7CC89D-3142-46AB-8DEE-A39EF376CEDE}" type="datetimeFigureOut">
               <a:rPr lang="en-GB" smtClean="0"/>
-              <a:t>03/07/2026</a:t>
+              <a:t>05/08/2026</a:t>
             </a:fld>
             <a:endParaRPr lang="en-GB"/>
           </a:p>
@@ -900,7 +900,7 @@
           <a:p>
             <a:fld id="{2E7CC89D-3142-46AB-8DEE-A39EF376CEDE}" type="datetimeFigureOut">
               <a:rPr lang="en-GB" smtClean="0"/>
-              <a:t>03/07/2026</a:t>
+              <a:t>05/08/2026</a:t>
             </a:fld>
             <a:endParaRPr lang="en-GB"/>
           </a:p>
@@ -1176,7 +1176,7 @@
           <a:p>
             <a:fld id="{2E7CC89D-3142-46AB-8DEE-A39EF376CEDE}" type="datetimeFigureOut">
               <a:rPr lang="en-GB" smtClean="0"/>
-              <a:t>03/07/2026</a:t>
+              <a:t>05/08/2026</a:t>
             </a:fld>
             <a:endParaRPr lang="en-GB"/>
           </a:p>
@@ -1444,7 +1444,7 @@
           <a:p>
             <a:fld id="{2E7CC89D-3142-46AB-8DEE-A39EF376CEDE}" type="datetimeFigureOut">
               <a:rPr lang="en-GB" smtClean="0"/>
-              <a:t>03/07/2026</a:t>
+              <a:t>05/08/2026</a:t>
             </a:fld>
             <a:endParaRPr lang="en-GB"/>
           </a:p>
@@ -1859,7 +1859,7 @@
           <a:p>
             <a:fld id="{2E7CC89D-3142-46AB-8DEE-A39EF376CEDE}" type="datetimeFigureOut">
               <a:rPr lang="en-GB" smtClean="0"/>
-              <a:t>03/07/2026</a:t>
+              <a:t>05/08/2026</a:t>
             </a:fld>
             <a:endParaRPr lang="en-GB"/>
           </a:p>
@@ -2001,7 +2001,7 @@
           <a:p>
             <a:fld id="{2E7CC89D-3142-46AB-8DEE-A39EF376CEDE}" type="datetimeFigureOut">
               <a:rPr lang="en-GB" smtClean="0"/>
-              <a:t>03/07/2026</a:t>
+              <a:t>05/08/2026</a:t>
             </a:fld>
             <a:endParaRPr lang="en-GB"/>
           </a:p>
@@ -2114,7 +2114,7 @@
           <a:p>
             <a:fld id="{2E7CC89D-3142-46AB-8DEE-A39EF376CEDE}" type="datetimeFigureOut">
               <a:rPr lang="en-GB" smtClean="0"/>
-              <a:t>03/07/2026</a:t>
+              <a:t>05/08/2026</a:t>
             </a:fld>
             <a:endParaRPr lang="en-GB"/>
           </a:p>
@@ -2427,7 +2427,7 @@
           <a:p>
             <a:fld id="{2E7CC89D-3142-46AB-8DEE-A39EF376CEDE}" type="datetimeFigureOut">
               <a:rPr lang="en-GB" smtClean="0"/>
-              <a:t>03/07/2026</a:t>
+              <a:t>05/08/2026</a:t>
             </a:fld>
             <a:endParaRPr lang="en-GB"/>
           </a:p>
@@ -2716,7 +2716,7 @@
           <a:p>
             <a:fld id="{2E7CC89D-3142-46AB-8DEE-A39EF376CEDE}" type="datetimeFigureOut">
               <a:rPr lang="en-GB" smtClean="0"/>
-              <a:t>03/07/2026</a:t>
+              <a:t>05/08/2026</a:t>
             </a:fld>
             <a:endParaRPr lang="en-GB"/>
           </a:p>
@@ -2959,7 +2959,7 @@
           <a:p>
             <a:fld id="{2E7CC89D-3142-46AB-8DEE-A39EF376CEDE}" type="datetimeFigureOut">
               <a:rPr lang="en-GB" smtClean="0"/>
-              <a:t>03/07/2026</a:t>
+              <a:t>05/08/2026</a:t>
             </a:fld>
             <a:endParaRPr lang="en-GB"/>
           </a:p>
@@ -3378,10 +3378,10 @@
       </p:grpSpPr>
       <p:pic>
         <p:nvPicPr>
-          <p:cNvPr id="3" name="Picture 2">
-            <a:extLst>
-              <a:ext uri="{FF2B5EF4-FFF2-40B4-BE49-F238E27FC236}">
-                <a16:creationId xmlns:a16="http://schemas.microsoft.com/office/drawing/2014/main" id="{C90706C7-E382-46CE-B94D-BEA84F4A15E6}"/>
+          <p:cNvPr id="4" name="Picture 3">
+            <a:extLst>
+              <a:ext uri="{FF2B5EF4-FFF2-40B4-BE49-F238E27FC236}">
+                <a16:creationId xmlns:a16="http://schemas.microsoft.com/office/drawing/2014/main" id="{0CBC58B2-7181-09AB-A494-0F1E536346A2}"/>
               </a:ext>
             </a:extLst>
           </p:cNvPr>
@@ -3398,8 +3398,8 @@
         </p:blipFill>
         <p:spPr>
           <a:xfrm>
-            <a:off x="3333682" y="612097"/>
-            <a:ext cx="8487960" cy="4848902"/>
+            <a:off x="3362844" y="633616"/>
+            <a:ext cx="8707065" cy="4848902"/>
           </a:xfrm>
           <a:prstGeom prst="rect">
             <a:avLst/>
@@ -3729,10 +3729,10 @@
       </p:grpSpPr>
       <p:pic>
         <p:nvPicPr>
-          <p:cNvPr id="23" name="Picture 22">
-            <a:extLst>
-              <a:ext uri="{FF2B5EF4-FFF2-40B4-BE49-F238E27FC236}">
-                <a16:creationId xmlns:a16="http://schemas.microsoft.com/office/drawing/2014/main" id="{6D9DA679-A214-4DBF-86C4-D27A244E4F35}"/>
+          <p:cNvPr id="2" name="Picture 1">
+            <a:extLst>
+              <a:ext uri="{FF2B5EF4-FFF2-40B4-BE49-F238E27FC236}">
+                <a16:creationId xmlns:a16="http://schemas.microsoft.com/office/drawing/2014/main" id="{C300CF9B-8941-C932-ECCD-24F12588C18B}"/>
               </a:ext>
             </a:extLst>
           </p:cNvPr>
@@ -3749,8 +3749,8 @@
         </p:blipFill>
         <p:spPr>
           <a:xfrm>
-            <a:off x="3319104" y="635697"/>
-            <a:ext cx="8840434" cy="5925377"/>
+            <a:off x="3319712" y="636622"/>
+            <a:ext cx="9297698" cy="5944430"/>
           </a:xfrm>
           <a:prstGeom prst="rect">
             <a:avLst/>
@@ -4305,7 +4305,7 @@
                   <a:srgbClr val="A41AE4"/>
                 </a:solidFill>
               </a:rPr>
-              <a:t>e.g., 2.61/10 = 0.26</a:t>
+              <a:t>e.g., 2.86/10 = 0.29</a:t>
             </a:r>
           </a:p>
           <a:p>
@@ -4315,7 +4315,7 @@
                   <a:srgbClr val="A41AE4"/>
                 </a:solidFill>
               </a:rPr>
-              <a:t>26% of the total variance is explained by Factor 1</a:t>
+              <a:t>29% of the total variance is explained by Factor 1</a:t>
             </a:r>
           </a:p>
         </p:txBody>
@@ -4443,10 +4443,10 @@
       </p:grpSpPr>
       <p:pic>
         <p:nvPicPr>
-          <p:cNvPr id="18" name="Picture 17">
-            <a:extLst>
-              <a:ext uri="{FF2B5EF4-FFF2-40B4-BE49-F238E27FC236}">
-                <a16:creationId xmlns:a16="http://schemas.microsoft.com/office/drawing/2014/main" id="{C1041EAC-3A25-4481-910E-871508200C14}"/>
+          <p:cNvPr id="2" name="Picture 1">
+            <a:extLst>
+              <a:ext uri="{FF2B5EF4-FFF2-40B4-BE49-F238E27FC236}">
+                <a16:creationId xmlns:a16="http://schemas.microsoft.com/office/drawing/2014/main" id="{31F140A5-A129-8A5D-B66E-741D61FFBBB3}"/>
               </a:ext>
             </a:extLst>
           </p:cNvPr>
@@ -4463,8 +4463,8 @@
         </p:blipFill>
         <p:spPr>
           <a:xfrm>
-            <a:off x="3319104" y="635697"/>
-            <a:ext cx="8840434" cy="5925377"/>
+            <a:off x="3319712" y="636622"/>
+            <a:ext cx="9297698" cy="5944430"/>
           </a:xfrm>
           <a:prstGeom prst="rect">
             <a:avLst/>
@@ -5019,7 +5019,7 @@
                   <a:srgbClr val="A41AE4"/>
                 </a:solidFill>
               </a:rPr>
-              <a:t>e.g., 0.26+0.25 = 0.51</a:t>
+              <a:t>e.g., 0.29+0.25 = 0.53</a:t>
             </a:r>
           </a:p>
         </p:txBody>
@@ -5147,10 +5147,10 @@
       </p:grpSpPr>
       <p:pic>
         <p:nvPicPr>
-          <p:cNvPr id="22" name="Picture 21">
-            <a:extLst>
-              <a:ext uri="{FF2B5EF4-FFF2-40B4-BE49-F238E27FC236}">
-                <a16:creationId xmlns:a16="http://schemas.microsoft.com/office/drawing/2014/main" id="{79FE0EBA-378E-453A-980C-788C38C61D47}"/>
+          <p:cNvPr id="2" name="Picture 1">
+            <a:extLst>
+              <a:ext uri="{FF2B5EF4-FFF2-40B4-BE49-F238E27FC236}">
+                <a16:creationId xmlns:a16="http://schemas.microsoft.com/office/drawing/2014/main" id="{21FE2781-9C2E-B0C4-EC77-B02840BBD4A4}"/>
               </a:ext>
             </a:extLst>
           </p:cNvPr>
@@ -5167,8 +5167,8 @@
         </p:blipFill>
         <p:spPr>
           <a:xfrm>
-            <a:off x="3319104" y="635697"/>
-            <a:ext cx="8840434" cy="5925377"/>
+            <a:off x="3319712" y="636622"/>
+            <a:ext cx="9297698" cy="5944430"/>
           </a:xfrm>
           <a:prstGeom prst="rect">
             <a:avLst/>
@@ -5723,7 +5723,7 @@
                   <a:srgbClr val="A41AE4"/>
                 </a:solidFill>
               </a:rPr>
-              <a:t>e.g., 0.25/0.51 = 0.49</a:t>
+              <a:t>e.g., 0.29/0.53 = 0.54</a:t>
             </a:r>
           </a:p>
           <a:p>
@@ -5868,10 +5868,10 @@
       </p:grpSpPr>
       <p:pic>
         <p:nvPicPr>
-          <p:cNvPr id="23" name="Picture 22">
-            <a:extLst>
-              <a:ext uri="{FF2B5EF4-FFF2-40B4-BE49-F238E27FC236}">
-                <a16:creationId xmlns:a16="http://schemas.microsoft.com/office/drawing/2014/main" id="{29F32B6B-13DC-4465-811B-88FF939F0332}"/>
+          <p:cNvPr id="2" name="Picture 1">
+            <a:extLst>
+              <a:ext uri="{FF2B5EF4-FFF2-40B4-BE49-F238E27FC236}">
+                <a16:creationId xmlns:a16="http://schemas.microsoft.com/office/drawing/2014/main" id="{030F11DF-D520-D5A5-1F1F-819D30AF98ED}"/>
               </a:ext>
             </a:extLst>
           </p:cNvPr>
@@ -5888,8 +5888,8 @@
         </p:blipFill>
         <p:spPr>
           <a:xfrm>
-            <a:off x="3319104" y="635697"/>
-            <a:ext cx="8840434" cy="5925377"/>
+            <a:off x="3319712" y="636622"/>
+            <a:ext cx="9297698" cy="5944430"/>
           </a:xfrm>
           <a:prstGeom prst="rect">
             <a:avLst/>
@@ -6592,10 +6592,10 @@
       </p:grpSpPr>
       <p:pic>
         <p:nvPicPr>
-          <p:cNvPr id="4" name="Picture 3">
-            <a:extLst>
-              <a:ext uri="{FF2B5EF4-FFF2-40B4-BE49-F238E27FC236}">
-                <a16:creationId xmlns:a16="http://schemas.microsoft.com/office/drawing/2014/main" id="{6809D7AC-4C00-4618-BBFC-F89D6A029695}"/>
+          <p:cNvPr id="3" name="Picture 2">
+            <a:extLst>
+              <a:ext uri="{FF2B5EF4-FFF2-40B4-BE49-F238E27FC236}">
+                <a16:creationId xmlns:a16="http://schemas.microsoft.com/office/drawing/2014/main" id="{F6FA69FB-C04D-E678-D171-EE3D7DA87898}"/>
               </a:ext>
             </a:extLst>
           </p:cNvPr>
@@ -6612,8 +6612,8 @@
         </p:blipFill>
         <p:spPr>
           <a:xfrm>
-            <a:off x="2580184" y="1436130"/>
-            <a:ext cx="9497750" cy="4839375"/>
+            <a:off x="2563981" y="1453934"/>
+            <a:ext cx="9459645" cy="4791744"/>
           </a:xfrm>
           <a:prstGeom prst="rect">
             <a:avLst/>
@@ -7802,10 +7802,10 @@
       </p:grpSpPr>
       <p:pic>
         <p:nvPicPr>
-          <p:cNvPr id="17" name="Picture 16">
-            <a:extLst>
-              <a:ext uri="{FF2B5EF4-FFF2-40B4-BE49-F238E27FC236}">
-                <a16:creationId xmlns:a16="http://schemas.microsoft.com/office/drawing/2014/main" id="{25BA699C-3307-452E-A0E3-9BF745AD5103}"/>
+          <p:cNvPr id="7" name="Picture 6">
+            <a:extLst>
+              <a:ext uri="{FF2B5EF4-FFF2-40B4-BE49-F238E27FC236}">
+                <a16:creationId xmlns:a16="http://schemas.microsoft.com/office/drawing/2014/main" id="{3AAD7C37-EE9A-CEB8-1906-0DC12A038DCD}"/>
               </a:ext>
             </a:extLst>
           </p:cNvPr>
@@ -7822,8 +7822,8 @@
         </p:blipFill>
         <p:spPr>
           <a:xfrm>
-            <a:off x="2580184" y="1436130"/>
-            <a:ext cx="9497750" cy="4839375"/>
+            <a:off x="2563981" y="1453934"/>
+            <a:ext cx="9459645" cy="4791744"/>
           </a:xfrm>
           <a:prstGeom prst="rect">
             <a:avLst/>
@@ -8468,10 +8468,10 @@
       </p:grpSpPr>
       <p:pic>
         <p:nvPicPr>
-          <p:cNvPr id="13" name="Picture 12">
-            <a:extLst>
-              <a:ext uri="{FF2B5EF4-FFF2-40B4-BE49-F238E27FC236}">
-                <a16:creationId xmlns:a16="http://schemas.microsoft.com/office/drawing/2014/main" id="{6162FFCA-0132-41A4-930C-5E37477E1CA8}"/>
+          <p:cNvPr id="2" name="Picture 1">
+            <a:extLst>
+              <a:ext uri="{FF2B5EF4-FFF2-40B4-BE49-F238E27FC236}">
+                <a16:creationId xmlns:a16="http://schemas.microsoft.com/office/drawing/2014/main" id="{0E56FF8C-8BFC-A2DF-CD4C-8C9793B096DE}"/>
               </a:ext>
             </a:extLst>
           </p:cNvPr>
@@ -8488,8 +8488,8 @@
         </p:blipFill>
         <p:spPr>
           <a:xfrm>
-            <a:off x="2580184" y="1436130"/>
-            <a:ext cx="9497750" cy="4839375"/>
+            <a:off x="2563981" y="1453934"/>
+            <a:ext cx="9459645" cy="4791744"/>
           </a:xfrm>
           <a:prstGeom prst="rect">
             <a:avLst/>
@@ -10500,10 +10500,10 @@
       </p:grpSpPr>
       <p:pic>
         <p:nvPicPr>
-          <p:cNvPr id="13" name="Picture 12">
-            <a:extLst>
-              <a:ext uri="{FF2B5EF4-FFF2-40B4-BE49-F238E27FC236}">
-                <a16:creationId xmlns:a16="http://schemas.microsoft.com/office/drawing/2014/main" id="{0C34FE87-FE6E-414A-9F06-179887601AE1}"/>
+          <p:cNvPr id="2" name="Picture 1">
+            <a:extLst>
+              <a:ext uri="{FF2B5EF4-FFF2-40B4-BE49-F238E27FC236}">
+                <a16:creationId xmlns:a16="http://schemas.microsoft.com/office/drawing/2014/main" id="{2011BB46-331F-B4E7-ACC9-F30FDC6513EA}"/>
               </a:ext>
             </a:extLst>
           </p:cNvPr>
@@ -10520,8 +10520,8 @@
         </p:blipFill>
         <p:spPr>
           <a:xfrm>
-            <a:off x="3333682" y="612097"/>
-            <a:ext cx="8487960" cy="4848902"/>
+            <a:off x="3362844" y="633616"/>
+            <a:ext cx="8707065" cy="4848902"/>
           </a:xfrm>
           <a:prstGeom prst="rect">
             <a:avLst/>
@@ -10968,10 +10968,10 @@
       </p:grpSpPr>
       <p:pic>
         <p:nvPicPr>
-          <p:cNvPr id="22" name="Picture 21">
-            <a:extLst>
-              <a:ext uri="{FF2B5EF4-FFF2-40B4-BE49-F238E27FC236}">
-                <a16:creationId xmlns:a16="http://schemas.microsoft.com/office/drawing/2014/main" id="{68487281-47C8-43DD-A154-EC1204828D09}"/>
+          <p:cNvPr id="2" name="Picture 1">
+            <a:extLst>
+              <a:ext uri="{FF2B5EF4-FFF2-40B4-BE49-F238E27FC236}">
+                <a16:creationId xmlns:a16="http://schemas.microsoft.com/office/drawing/2014/main" id="{88E5C3AC-DB78-1326-1D46-034C0AF77B84}"/>
               </a:ext>
             </a:extLst>
           </p:cNvPr>
@@ -10988,8 +10988,8 @@
         </p:blipFill>
         <p:spPr>
           <a:xfrm>
-            <a:off x="3333682" y="612097"/>
-            <a:ext cx="8487960" cy="4848902"/>
+            <a:off x="3362844" y="633616"/>
+            <a:ext cx="8707065" cy="4848902"/>
           </a:xfrm>
           <a:prstGeom prst="rect">
             <a:avLst/>
@@ -11279,7 +11279,7 @@
                   <a:srgbClr val="A41AE4"/>
                 </a:solidFill>
               </a:rPr>
-              <a:t>e.g., 0.50</a:t>
+              <a:t>e.g., 0.51</a:t>
             </a:r>
             <a:r>
               <a:rPr lang="en-GB" sz="1400" b="0" i="0" dirty="0">
@@ -11297,7 +11297,7 @@
                   <a:srgbClr val="A41AE4"/>
                 </a:solidFill>
               </a:rPr>
-              <a:t> = 0.25</a:t>
+              <a:t> = 0.26</a:t>
             </a:r>
           </a:p>
           <a:p>
@@ -11307,7 +11307,7 @@
                   <a:srgbClr val="A41AE4"/>
                 </a:solidFill>
               </a:rPr>
-              <a:t>25% of the variance in Q10 is explained by Factor 2</a:t>
+              <a:t>26% of the variance in Q10 is explained by Factor 1</a:t>
             </a:r>
           </a:p>
         </p:txBody>
@@ -11556,7 +11556,7 @@
                     <a:schemeClr val="tx1"/>
                   </a:solidFill>
                 </a:rPr>
-                <a:t>       ML2</a:t>
+                <a:t>      MR2</a:t>
               </a:r>
             </a:p>
           </p:txBody>
@@ -11615,7 +11615,7 @@
                     <a:schemeClr val="tx1"/>
                   </a:solidFill>
                 </a:rPr>
-                <a:t>ML1</a:t>
+                <a:t>MR1</a:t>
               </a:r>
             </a:p>
           </p:txBody>
@@ -11656,7 +11656,7 @@
             <a:p>
               <a:r>
                 <a:rPr lang="en-GB" sz="1200" dirty="0"/>
-                <a:t>means that ML1 and ML2 are uncorrelated (no overlap)</a:t>
+                <a:t>means that MR1 and MR2 are uncorrelated (no overlap)</a:t>
               </a:r>
             </a:p>
           </p:txBody>
@@ -11742,7 +11742,7 @@
                     <a:schemeClr val="accent6"/>
                   </a:solidFill>
                 </a:rPr>
-                <a:t>Variance in Q10 explained by ML2</a:t>
+                <a:t>Variance in Q10 explained by MR2</a:t>
               </a:r>
             </a:p>
           </p:txBody>
@@ -11806,7 +11806,7 @@
           <p:spPr>
             <a:xfrm>
               <a:off x="486440" y="878547"/>
-              <a:ext cx="1277596" cy="461665"/>
+              <a:ext cx="1350538" cy="461665"/>
             </a:xfrm>
             <a:prstGeom prst="rect">
               <a:avLst/>
@@ -11825,7 +11825,7 @@
                     <a:schemeClr val="accent6"/>
                   </a:solidFill>
                 </a:rPr>
-                <a:t>Variance in Q10 explained by ML1</a:t>
+                <a:t>Variance in Q10 explained by MR1</a:t>
               </a:r>
             </a:p>
           </p:txBody>
@@ -11915,10 +11915,10 @@
       </p:grpSpPr>
       <p:pic>
         <p:nvPicPr>
-          <p:cNvPr id="39" name="Picture 38">
-            <a:extLst>
-              <a:ext uri="{FF2B5EF4-FFF2-40B4-BE49-F238E27FC236}">
-                <a16:creationId xmlns:a16="http://schemas.microsoft.com/office/drawing/2014/main" id="{97DC3891-E3E1-4E31-8C22-90E0292E9E90}"/>
+          <p:cNvPr id="3" name="Picture 2">
+            <a:extLst>
+              <a:ext uri="{FF2B5EF4-FFF2-40B4-BE49-F238E27FC236}">
+                <a16:creationId xmlns:a16="http://schemas.microsoft.com/office/drawing/2014/main" id="{C535CA0D-2967-7A38-A970-69FF717FCEED}"/>
               </a:ext>
             </a:extLst>
           </p:cNvPr>
@@ -11935,8 +11935,8 @@
         </p:blipFill>
         <p:spPr>
           <a:xfrm>
-            <a:off x="3319104" y="635697"/>
-            <a:ext cx="8840434" cy="5925377"/>
+            <a:off x="3319712" y="636622"/>
+            <a:ext cx="9297698" cy="5944430"/>
           </a:xfrm>
           <a:prstGeom prst="rect">
             <a:avLst/>
@@ -12255,7 +12255,23 @@
                   <a:srgbClr val="A41AE4"/>
                 </a:solidFill>
               </a:rPr>
-              <a:t>A squared loading reflects the proportion of variance in an item that is uniquely explained by a factor.  </a:t>
+              <a:t>A squared loading reflects the proportion of variance in an item that is </a:t>
+            </a:r>
+            <a:r>
+              <a:rPr lang="en-GB" b="1" dirty="0">
+                <a:solidFill>
+                  <a:srgbClr val="A41AE4"/>
+                </a:solidFill>
+              </a:rPr>
+              <a:t>uniquely</a:t>
+            </a:r>
+            <a:r>
+              <a:rPr lang="en-GB" dirty="0">
+                <a:solidFill>
+                  <a:srgbClr val="A41AE4"/>
+                </a:solidFill>
+              </a:rPr>
+              <a:t> explained by a factor.  </a:t>
             </a:r>
           </a:p>
           <a:p>
@@ -12265,7 +12281,7 @@
                   <a:srgbClr val="A41AE4"/>
                 </a:solidFill>
               </a:rPr>
-              <a:t>e.g., 0.60</a:t>
+              <a:t>e.g., 0.52</a:t>
             </a:r>
             <a:r>
               <a:rPr lang="en-GB" sz="1400" b="0" i="0" dirty="0">
@@ -12283,7 +12299,7 @@
                   <a:srgbClr val="A41AE4"/>
                 </a:solidFill>
               </a:rPr>
-              <a:t> = 0.36</a:t>
+              <a:t> = 0.27</a:t>
             </a:r>
           </a:p>
           <a:p>
@@ -12293,7 +12309,7 @@
                   <a:srgbClr val="A41AE4"/>
                 </a:solidFill>
               </a:rPr>
-              <a:t>36% of the variance in Q10 is explained by Factor 2</a:t>
+              <a:t>27% of the variance in Q10 is explained by Factor 2</a:t>
             </a:r>
           </a:p>
         </p:txBody>
@@ -12485,477 +12501,216 @@
           </a:fontRef>
         </p:style>
       </p:cxnSp>
-      <p:grpSp>
-        <p:nvGrpSpPr>
-          <p:cNvPr id="15" name="Group 14">
-            <a:extLst>
-              <a:ext uri="{FF2B5EF4-FFF2-40B4-BE49-F238E27FC236}">
-                <a16:creationId xmlns:a16="http://schemas.microsoft.com/office/drawing/2014/main" id="{0354BDAE-A5CD-4F11-9828-040C16236B48}"/>
-              </a:ext>
-            </a:extLst>
-          </p:cNvPr>
-          <p:cNvGrpSpPr/>
+      <p:sp>
+        <p:nvSpPr>
+          <p:cNvPr id="20" name="TextBox 19">
+            <a:extLst>
+              <a:ext uri="{FF2B5EF4-FFF2-40B4-BE49-F238E27FC236}">
+                <a16:creationId xmlns:a16="http://schemas.microsoft.com/office/drawing/2014/main" id="{3E92A4EB-AD9F-4267-A16E-94E82451856B}"/>
+              </a:ext>
+            </a:extLst>
+          </p:cNvPr>
+          <p:cNvSpPr txBox="1"/>
           <p:nvPr/>
-        </p:nvGrpSpPr>
-        <p:grpSpPr>
+        </p:nvSpPr>
+        <p:spPr>
           <a:xfrm>
-            <a:off x="6993392" y="4331940"/>
-            <a:ext cx="4897889" cy="2329211"/>
-            <a:chOff x="5511259" y="3397660"/>
-            <a:chExt cx="4897889" cy="2329211"/>
-          </a:xfrm>
-        </p:grpSpPr>
-        <p:sp>
-          <p:nvSpPr>
-            <p:cNvPr id="16" name="Oval 15">
-              <a:extLst>
-                <a:ext uri="{FF2B5EF4-FFF2-40B4-BE49-F238E27FC236}">
-                  <a16:creationId xmlns:a16="http://schemas.microsoft.com/office/drawing/2014/main" id="{76E2686C-066A-4E80-91BB-208B27ED24EA}"/>
-                </a:ext>
-              </a:extLst>
-            </p:cNvPr>
-            <p:cNvSpPr/>
-            <p:nvPr/>
-          </p:nvSpPr>
-          <p:spPr>
-            <a:xfrm>
-              <a:off x="6783242" y="3771053"/>
-              <a:ext cx="1100667" cy="1077218"/>
-            </a:xfrm>
-            <a:prstGeom prst="ellipse">
-              <a:avLst/>
-            </a:prstGeom>
+            <a:off x="9813751" y="6006801"/>
+            <a:ext cx="2077530" cy="646331"/>
+          </a:xfrm>
+          <a:prstGeom prst="rect">
+            <a:avLst/>
+          </a:prstGeom>
+          <a:noFill/>
+        </p:spPr>
+        <p:txBody>
+          <a:bodyPr wrap="square" rtlCol="0">
+            <a:spAutoFit/>
+          </a:bodyPr>
+          <a:lstStyle/>
+          <a:p>
+            <a:r>
+              <a:rPr lang="en-GB" sz="1200" dirty="0"/>
+              <a:t>oblique rotation</a:t>
+            </a:r>
+          </a:p>
+          <a:p>
+            <a:r>
+              <a:rPr lang="en-GB" sz="1200" dirty="0"/>
+              <a:t>means that MR1 and MR2 are correlated (overlap)</a:t>
+            </a:r>
+          </a:p>
+        </p:txBody>
+      </p:sp>
+      <p:cxnSp>
+        <p:nvCxnSpPr>
+          <p:cNvPr id="22" name="Straight Arrow Connector 21">
+            <a:extLst>
+              <a:ext uri="{FF2B5EF4-FFF2-40B4-BE49-F238E27FC236}">
+                <a16:creationId xmlns:a16="http://schemas.microsoft.com/office/drawing/2014/main" id="{A46ACA3C-3292-4663-AB0A-6EE8E3992798}"/>
+              </a:ext>
+            </a:extLst>
+          </p:cNvPr>
+          <p:cNvCxnSpPr>
+            <a:cxnSpLocks/>
+          </p:cNvCxnSpPr>
+          <p:nvPr/>
+        </p:nvCxnSpPr>
+        <p:spPr>
+          <a:xfrm flipH="1">
+            <a:off x="9187858" y="4768515"/>
+            <a:ext cx="469013" cy="589416"/>
+          </a:xfrm>
+          <a:prstGeom prst="straightConnector1">
+            <a:avLst/>
+          </a:prstGeom>
+          <a:ln>
+            <a:solidFill>
+              <a:schemeClr val="accent6"/>
+            </a:solidFill>
+            <a:tailEnd type="triangle"/>
+          </a:ln>
+        </p:spPr>
+        <p:style>
+          <a:lnRef idx="1">
+            <a:schemeClr val="accent1"/>
+          </a:lnRef>
+          <a:fillRef idx="0">
+            <a:schemeClr val="accent1"/>
+          </a:fillRef>
+          <a:effectRef idx="0">
+            <a:schemeClr val="accent1"/>
+          </a:effectRef>
+          <a:fontRef idx="minor">
+            <a:schemeClr val="tx1"/>
+          </a:fontRef>
+        </p:style>
+      </p:cxnSp>
+      <p:sp>
+        <p:nvSpPr>
+          <p:cNvPr id="25" name="TextBox 24">
+            <a:extLst>
+              <a:ext uri="{FF2B5EF4-FFF2-40B4-BE49-F238E27FC236}">
+                <a16:creationId xmlns:a16="http://schemas.microsoft.com/office/drawing/2014/main" id="{10283DB4-D201-4FD8-9270-1892B113A965}"/>
+              </a:ext>
+            </a:extLst>
+          </p:cNvPr>
+          <p:cNvSpPr txBox="1"/>
+          <p:nvPr/>
+        </p:nvSpPr>
+        <p:spPr>
+          <a:xfrm>
+            <a:off x="9415606" y="4331940"/>
+            <a:ext cx="1371601" cy="461665"/>
+          </a:xfrm>
+          <a:prstGeom prst="rect">
+            <a:avLst/>
+          </a:prstGeom>
+          <a:noFill/>
+          <a:ln>
             <a:noFill/>
-            <a:ln>
-              <a:solidFill>
-                <a:schemeClr val="tx1"/>
-              </a:solidFill>
-            </a:ln>
-          </p:spPr>
-          <p:style>
-            <a:lnRef idx="2">
-              <a:schemeClr val="accent1">
-                <a:shade val="50000"/>
-              </a:schemeClr>
-            </a:lnRef>
-            <a:fillRef idx="1">
-              <a:schemeClr val="accent1"/>
-            </a:fillRef>
-            <a:effectRef idx="0">
-              <a:schemeClr val="accent1"/>
-            </a:effectRef>
-            <a:fontRef idx="minor">
-              <a:schemeClr val="lt1"/>
-            </a:fontRef>
-          </p:style>
-          <p:txBody>
-            <a:bodyPr rtlCol="0" anchor="ctr"/>
-            <a:lstStyle/>
-            <a:p>
-              <a:r>
-                <a:rPr lang="en-GB" sz="1400" dirty="0">
-                  <a:solidFill>
-                    <a:schemeClr val="tx1"/>
-                  </a:solidFill>
-                </a:rPr>
-                <a:t>Q10               </a:t>
-              </a:r>
-            </a:p>
-            <a:p>
-              <a:pPr algn="ctr"/>
-              <a:endParaRPr lang="en-GB" sz="1400" dirty="0">
-                <a:solidFill>
-                  <a:schemeClr val="tx1"/>
-                </a:solidFill>
-              </a:endParaRPr>
-            </a:p>
-            <a:p>
-              <a:pPr algn="ctr"/>
-              <a:endParaRPr lang="en-GB" sz="1400" dirty="0">
-                <a:solidFill>
-                  <a:schemeClr val="tx1"/>
-                </a:solidFill>
-              </a:endParaRPr>
-            </a:p>
-          </p:txBody>
-        </p:sp>
-        <p:sp>
-          <p:nvSpPr>
-            <p:cNvPr id="17" name="Oval 16">
-              <a:extLst>
-                <a:ext uri="{FF2B5EF4-FFF2-40B4-BE49-F238E27FC236}">
-                  <a16:creationId xmlns:a16="http://schemas.microsoft.com/office/drawing/2014/main" id="{F1000354-F43C-4474-AC92-25D3084E1CC2}"/>
-                </a:ext>
-              </a:extLst>
-            </p:cNvPr>
-            <p:cNvSpPr/>
-            <p:nvPr/>
-          </p:nvSpPr>
-          <p:spPr>
-            <a:xfrm>
-              <a:off x="7297270" y="3987241"/>
-              <a:ext cx="1100667" cy="1077218"/>
-            </a:xfrm>
-            <a:prstGeom prst="ellipse">
-              <a:avLst/>
-            </a:prstGeom>
-            <a:noFill/>
-            <a:ln>
-              <a:solidFill>
-                <a:schemeClr val="tx1"/>
-              </a:solidFill>
-            </a:ln>
-          </p:spPr>
-          <p:style>
-            <a:lnRef idx="2">
-              <a:schemeClr val="accent1">
-                <a:shade val="50000"/>
-              </a:schemeClr>
-            </a:lnRef>
-            <a:fillRef idx="1">
-              <a:schemeClr val="accent1"/>
-            </a:fillRef>
-            <a:effectRef idx="0">
-              <a:schemeClr val="accent1"/>
-            </a:effectRef>
-            <a:fontRef idx="minor">
-              <a:schemeClr val="lt1"/>
-            </a:fontRef>
-          </p:style>
-          <p:txBody>
-            <a:bodyPr rtlCol="0" anchor="ctr"/>
-            <a:lstStyle/>
-            <a:p>
-              <a:pPr algn="ctr"/>
-              <a:r>
-                <a:rPr lang="en-GB" sz="1400" dirty="0">
-                  <a:solidFill>
-                    <a:schemeClr val="tx1"/>
-                  </a:solidFill>
-                </a:rPr>
-                <a:t>       </a:t>
-              </a:r>
-            </a:p>
-            <a:p>
-              <a:pPr algn="ctr"/>
-              <a:endParaRPr lang="en-GB" sz="1400" dirty="0">
-                <a:solidFill>
-                  <a:schemeClr val="tx1"/>
-                </a:solidFill>
-              </a:endParaRPr>
-            </a:p>
-            <a:p>
-              <a:pPr algn="ctr"/>
-              <a:endParaRPr lang="en-GB" sz="1400" dirty="0">
-                <a:solidFill>
-                  <a:schemeClr val="tx1"/>
-                </a:solidFill>
-              </a:endParaRPr>
-            </a:p>
-            <a:p>
-              <a:pPr algn="ctr"/>
-              <a:endParaRPr lang="en-GB" sz="1400" dirty="0">
-                <a:solidFill>
-                  <a:schemeClr val="tx1"/>
-                </a:solidFill>
-              </a:endParaRPr>
-            </a:p>
-          </p:txBody>
-        </p:sp>
-        <p:sp>
-          <p:nvSpPr>
-            <p:cNvPr id="18" name="Oval 17">
-              <a:extLst>
-                <a:ext uri="{FF2B5EF4-FFF2-40B4-BE49-F238E27FC236}">
-                  <a16:creationId xmlns:a16="http://schemas.microsoft.com/office/drawing/2014/main" id="{E7999FD8-209A-4AE2-A0F9-CF759F73B79B}"/>
-                </a:ext>
-              </a:extLst>
-            </p:cNvPr>
-            <p:cNvSpPr/>
-            <p:nvPr/>
-          </p:nvSpPr>
-          <p:spPr>
-            <a:xfrm>
-              <a:off x="7188033" y="4649653"/>
-              <a:ext cx="1100667" cy="1077218"/>
-            </a:xfrm>
-            <a:prstGeom prst="ellipse">
-              <a:avLst/>
-            </a:prstGeom>
-            <a:noFill/>
-            <a:ln>
-              <a:solidFill>
-                <a:schemeClr val="tx1"/>
-              </a:solidFill>
-            </a:ln>
-          </p:spPr>
-          <p:style>
-            <a:lnRef idx="2">
-              <a:schemeClr val="accent1">
-                <a:shade val="50000"/>
-              </a:schemeClr>
-            </a:lnRef>
-            <a:fillRef idx="1">
-              <a:schemeClr val="accent1"/>
-            </a:fillRef>
-            <a:effectRef idx="0">
-              <a:schemeClr val="accent1"/>
-            </a:effectRef>
-            <a:fontRef idx="minor">
-              <a:schemeClr val="lt1"/>
-            </a:fontRef>
-          </p:style>
-          <p:txBody>
-            <a:bodyPr rtlCol="0" anchor="ctr"/>
-            <a:lstStyle/>
-            <a:p>
-              <a:pPr algn="ctr"/>
-              <a:endParaRPr lang="en-GB" sz="1400" dirty="0">
-                <a:solidFill>
-                  <a:schemeClr val="tx1"/>
-                </a:solidFill>
-              </a:endParaRPr>
-            </a:p>
-            <a:p>
-              <a:pPr algn="ctr"/>
-              <a:endParaRPr lang="en-GB" sz="1400" dirty="0">
-                <a:solidFill>
-                  <a:schemeClr val="tx1"/>
-                </a:solidFill>
-              </a:endParaRPr>
-            </a:p>
-            <a:p>
-              <a:pPr algn="ctr"/>
-              <a:endParaRPr lang="en-GB" sz="1400" dirty="0">
-                <a:solidFill>
-                  <a:schemeClr val="tx1"/>
-                </a:solidFill>
-              </a:endParaRPr>
-            </a:p>
-            <a:p>
-              <a:pPr algn="ctr"/>
-              <a:r>
-                <a:rPr lang="en-GB" sz="1400" dirty="0">
-                  <a:solidFill>
-                    <a:schemeClr val="tx1"/>
-                  </a:solidFill>
-                </a:rPr>
-                <a:t>ML1</a:t>
-              </a:r>
-            </a:p>
-          </p:txBody>
-        </p:sp>
-        <p:sp>
-          <p:nvSpPr>
-            <p:cNvPr id="20" name="TextBox 19">
-              <a:extLst>
-                <a:ext uri="{FF2B5EF4-FFF2-40B4-BE49-F238E27FC236}">
-                  <a16:creationId xmlns:a16="http://schemas.microsoft.com/office/drawing/2014/main" id="{3E92A4EB-AD9F-4267-A16E-94E82451856B}"/>
-                </a:ext>
-              </a:extLst>
-            </p:cNvPr>
-            <p:cNvSpPr txBox="1"/>
-            <p:nvPr/>
-          </p:nvSpPr>
-          <p:spPr>
-            <a:xfrm>
-              <a:off x="8331618" y="5072521"/>
-              <a:ext cx="2077530" cy="646331"/>
-            </a:xfrm>
-            <a:prstGeom prst="rect">
-              <a:avLst/>
-            </a:prstGeom>
-            <a:noFill/>
-          </p:spPr>
-          <p:txBody>
-            <a:bodyPr wrap="square" rtlCol="0">
-              <a:spAutoFit/>
-            </a:bodyPr>
-            <a:lstStyle/>
-            <a:p>
-              <a:r>
-                <a:rPr lang="en-GB" sz="1200" dirty="0"/>
-                <a:t>oblique rotation</a:t>
-              </a:r>
-            </a:p>
-            <a:p>
-              <a:r>
-                <a:rPr lang="en-GB" sz="1200" dirty="0"/>
-                <a:t>means that ML1 and ML2 are correlated (overlap)</a:t>
-              </a:r>
-            </a:p>
-          </p:txBody>
-        </p:sp>
-        <p:cxnSp>
-          <p:nvCxnSpPr>
-            <p:cNvPr id="22" name="Straight Arrow Connector 21">
-              <a:extLst>
-                <a:ext uri="{FF2B5EF4-FFF2-40B4-BE49-F238E27FC236}">
-                  <a16:creationId xmlns:a16="http://schemas.microsoft.com/office/drawing/2014/main" id="{A46ACA3C-3292-4663-AB0A-6EE8E3992798}"/>
-                </a:ext>
-              </a:extLst>
-            </p:cNvPr>
-            <p:cNvCxnSpPr>
-              <a:cxnSpLocks/>
-            </p:cNvCxnSpPr>
-            <p:nvPr/>
-          </p:nvCxnSpPr>
-          <p:spPr>
-            <a:xfrm flipH="1">
-              <a:off x="7705725" y="3834235"/>
-              <a:ext cx="469013" cy="589416"/>
-            </a:xfrm>
-            <a:prstGeom prst="straightConnector1">
-              <a:avLst/>
-            </a:prstGeom>
-            <a:ln>
-              <a:solidFill>
-                <a:schemeClr val="accent6"/>
-              </a:solidFill>
-              <a:tailEnd type="triangle"/>
-            </a:ln>
-          </p:spPr>
-          <p:style>
-            <a:lnRef idx="1">
-              <a:schemeClr val="accent1"/>
-            </a:lnRef>
-            <a:fillRef idx="0">
-              <a:schemeClr val="accent1"/>
-            </a:fillRef>
-            <a:effectRef idx="0">
-              <a:schemeClr val="accent1"/>
-            </a:effectRef>
-            <a:fontRef idx="minor">
-              <a:schemeClr val="tx1"/>
-            </a:fontRef>
-          </p:style>
-        </p:cxnSp>
-        <p:sp>
-          <p:nvSpPr>
-            <p:cNvPr id="25" name="TextBox 24">
-              <a:extLst>
-                <a:ext uri="{FF2B5EF4-FFF2-40B4-BE49-F238E27FC236}">
-                  <a16:creationId xmlns:a16="http://schemas.microsoft.com/office/drawing/2014/main" id="{10283DB4-D201-4FD8-9270-1892B113A965}"/>
-                </a:ext>
-              </a:extLst>
-            </p:cNvPr>
-            <p:cNvSpPr txBox="1"/>
-            <p:nvPr/>
-          </p:nvSpPr>
-          <p:spPr>
-            <a:xfrm>
-              <a:off x="7933473" y="3397660"/>
-              <a:ext cx="1371601" cy="461665"/>
-            </a:xfrm>
-            <a:prstGeom prst="rect">
-              <a:avLst/>
-            </a:prstGeom>
-            <a:noFill/>
-            <a:ln>
-              <a:noFill/>
-            </a:ln>
-          </p:spPr>
-          <p:txBody>
-            <a:bodyPr wrap="square" rtlCol="0">
-              <a:spAutoFit/>
-            </a:bodyPr>
-            <a:lstStyle/>
-            <a:p>
-              <a:r>
-                <a:rPr lang="en-GB" sz="1200" dirty="0">
-                  <a:solidFill>
-                    <a:schemeClr val="accent6"/>
-                  </a:solidFill>
-                </a:rPr>
-                <a:t>Variance in Q10 explained by ML2</a:t>
-              </a:r>
-            </a:p>
-          </p:txBody>
-        </p:sp>
-        <p:cxnSp>
-          <p:nvCxnSpPr>
-            <p:cNvPr id="26" name="Straight Arrow Connector 25">
-              <a:extLst>
-                <a:ext uri="{FF2B5EF4-FFF2-40B4-BE49-F238E27FC236}">
-                  <a16:creationId xmlns:a16="http://schemas.microsoft.com/office/drawing/2014/main" id="{E3781CEF-26F8-44DA-B38C-38CAB16D92E5}"/>
-                </a:ext>
-              </a:extLst>
-            </p:cNvPr>
-            <p:cNvCxnSpPr>
-              <a:cxnSpLocks/>
-            </p:cNvCxnSpPr>
-            <p:nvPr/>
-          </p:nvCxnSpPr>
-          <p:spPr>
-            <a:xfrm flipV="1">
-              <a:off x="6649332" y="4827001"/>
-              <a:ext cx="709605" cy="365374"/>
-            </a:xfrm>
-            <a:prstGeom prst="straightConnector1">
-              <a:avLst/>
-            </a:prstGeom>
-            <a:ln>
-              <a:solidFill>
-                <a:schemeClr val="accent6"/>
-              </a:solidFill>
-              <a:tailEnd type="triangle"/>
-            </a:ln>
-          </p:spPr>
-          <p:style>
-            <a:lnRef idx="1">
-              <a:schemeClr val="accent1"/>
-            </a:lnRef>
-            <a:fillRef idx="0">
-              <a:schemeClr val="accent1"/>
-            </a:fillRef>
-            <a:effectRef idx="0">
-              <a:schemeClr val="accent1"/>
-            </a:effectRef>
-            <a:fontRef idx="minor">
-              <a:schemeClr val="tx1"/>
-            </a:fontRef>
-          </p:style>
-        </p:cxnSp>
-        <p:sp>
-          <p:nvSpPr>
-            <p:cNvPr id="27" name="TextBox 26">
-              <a:extLst>
-                <a:ext uri="{FF2B5EF4-FFF2-40B4-BE49-F238E27FC236}">
-                  <a16:creationId xmlns:a16="http://schemas.microsoft.com/office/drawing/2014/main" id="{3F4DD1CD-61A2-4684-9C5F-6BD70BC0C9CA}"/>
-                </a:ext>
-              </a:extLst>
-            </p:cNvPr>
-            <p:cNvSpPr txBox="1"/>
-            <p:nvPr/>
-          </p:nvSpPr>
-          <p:spPr>
-            <a:xfrm>
-              <a:off x="5511259" y="4976186"/>
-              <a:ext cx="1277596" cy="461665"/>
-            </a:xfrm>
-            <a:prstGeom prst="rect">
-              <a:avLst/>
-            </a:prstGeom>
-            <a:noFill/>
-          </p:spPr>
-          <p:txBody>
-            <a:bodyPr wrap="square" rtlCol="0">
-              <a:spAutoFit/>
-            </a:bodyPr>
-            <a:lstStyle/>
-            <a:p>
-              <a:r>
-                <a:rPr lang="en-GB" sz="1200" dirty="0">
-                  <a:solidFill>
-                    <a:schemeClr val="accent6"/>
-                  </a:solidFill>
-                </a:rPr>
-                <a:t>Variance in Q10 explained by ML1</a:t>
-              </a:r>
-            </a:p>
-          </p:txBody>
-        </p:sp>
-      </p:grpSp>
+          </a:ln>
+        </p:spPr>
+        <p:txBody>
+          <a:bodyPr wrap="square" rtlCol="0">
+            <a:spAutoFit/>
+          </a:bodyPr>
+          <a:lstStyle/>
+          <a:p>
+            <a:r>
+              <a:rPr lang="en-GB" sz="1200" dirty="0">
+                <a:solidFill>
+                  <a:schemeClr val="accent6"/>
+                </a:solidFill>
+              </a:rPr>
+              <a:t>Variance in Q10 explained by MR2</a:t>
+            </a:r>
+          </a:p>
+        </p:txBody>
+      </p:sp>
+      <p:cxnSp>
+        <p:nvCxnSpPr>
+          <p:cNvPr id="26" name="Straight Arrow Connector 25">
+            <a:extLst>
+              <a:ext uri="{FF2B5EF4-FFF2-40B4-BE49-F238E27FC236}">
+                <a16:creationId xmlns:a16="http://schemas.microsoft.com/office/drawing/2014/main" id="{E3781CEF-26F8-44DA-B38C-38CAB16D92E5}"/>
+              </a:ext>
+            </a:extLst>
+          </p:cNvPr>
+          <p:cNvCxnSpPr>
+            <a:cxnSpLocks/>
+          </p:cNvCxnSpPr>
+          <p:nvPr/>
+        </p:nvCxnSpPr>
+        <p:spPr>
+          <a:xfrm flipV="1">
+            <a:off x="8131465" y="5761281"/>
+            <a:ext cx="709605" cy="365374"/>
+          </a:xfrm>
+          <a:prstGeom prst="straightConnector1">
+            <a:avLst/>
+          </a:prstGeom>
+          <a:ln>
+            <a:solidFill>
+              <a:schemeClr val="accent6"/>
+            </a:solidFill>
+            <a:tailEnd type="triangle"/>
+          </a:ln>
+        </p:spPr>
+        <p:style>
+          <a:lnRef idx="1">
+            <a:schemeClr val="accent1"/>
+          </a:lnRef>
+          <a:fillRef idx="0">
+            <a:schemeClr val="accent1"/>
+          </a:fillRef>
+          <a:effectRef idx="0">
+            <a:schemeClr val="accent1"/>
+          </a:effectRef>
+          <a:fontRef idx="minor">
+            <a:schemeClr val="tx1"/>
+          </a:fontRef>
+        </p:style>
+      </p:cxnSp>
+      <p:sp>
+        <p:nvSpPr>
+          <p:cNvPr id="27" name="TextBox 26">
+            <a:extLst>
+              <a:ext uri="{FF2B5EF4-FFF2-40B4-BE49-F238E27FC236}">
+                <a16:creationId xmlns:a16="http://schemas.microsoft.com/office/drawing/2014/main" id="{3F4DD1CD-61A2-4684-9C5F-6BD70BC0C9CA}"/>
+              </a:ext>
+            </a:extLst>
+          </p:cNvPr>
+          <p:cNvSpPr txBox="1"/>
+          <p:nvPr/>
+        </p:nvSpPr>
+        <p:spPr>
+          <a:xfrm>
+            <a:off x="6993392" y="5910466"/>
+            <a:ext cx="1412902" cy="461665"/>
+          </a:xfrm>
+          <a:prstGeom prst="rect">
+            <a:avLst/>
+          </a:prstGeom>
+          <a:noFill/>
+        </p:spPr>
+        <p:txBody>
+          <a:bodyPr wrap="square" rtlCol="0">
+            <a:spAutoFit/>
+          </a:bodyPr>
+          <a:lstStyle/>
+          <a:p>
+            <a:r>
+              <a:rPr lang="en-GB" sz="1200" dirty="0">
+                <a:solidFill>
+                  <a:schemeClr val="accent6"/>
+                </a:solidFill>
+              </a:rPr>
+              <a:t>Variance in Q10 explained by MR1</a:t>
+            </a:r>
+          </a:p>
+        </p:txBody>
+      </p:sp>
       <p:pic>
         <p:nvPicPr>
           <p:cNvPr id="28" name="Picture 27">
@@ -13441,10 +13196,250 @@
       </p:grpSp>
       <p:sp>
         <p:nvSpPr>
-          <p:cNvPr id="37" name="TextBox 36">
-            <a:extLst>
-              <a:ext uri="{FF2B5EF4-FFF2-40B4-BE49-F238E27FC236}">
-                <a16:creationId xmlns:a16="http://schemas.microsoft.com/office/drawing/2014/main" id="{6FE539FA-241F-46F7-B1BA-B54BA0CE295E}"/>
+          <p:cNvPr id="4" name="Oval 3">
+            <a:extLst>
+              <a:ext uri="{FF2B5EF4-FFF2-40B4-BE49-F238E27FC236}">
+                <a16:creationId xmlns:a16="http://schemas.microsoft.com/office/drawing/2014/main" id="{E4895346-E5C2-EDE7-CA99-14DBB52F15E5}"/>
+              </a:ext>
+            </a:extLst>
+          </p:cNvPr>
+          <p:cNvSpPr/>
+          <p:nvPr/>
+        </p:nvSpPr>
+        <p:spPr>
+          <a:xfrm>
+            <a:off x="8837660" y="4992106"/>
+            <a:ext cx="1100667" cy="1077218"/>
+          </a:xfrm>
+          <a:prstGeom prst="ellipse">
+            <a:avLst/>
+          </a:prstGeom>
+          <a:noFill/>
+          <a:ln>
+            <a:solidFill>
+              <a:schemeClr val="tx1"/>
+            </a:solidFill>
+          </a:ln>
+        </p:spPr>
+        <p:style>
+          <a:lnRef idx="2">
+            <a:schemeClr val="accent1">
+              <a:shade val="50000"/>
+            </a:schemeClr>
+          </a:lnRef>
+          <a:fillRef idx="1">
+            <a:schemeClr val="accent1"/>
+          </a:fillRef>
+          <a:effectRef idx="0">
+            <a:schemeClr val="accent1"/>
+          </a:effectRef>
+          <a:fontRef idx="minor">
+            <a:schemeClr val="lt1"/>
+          </a:fontRef>
+        </p:style>
+        <p:txBody>
+          <a:bodyPr rtlCol="0" anchor="ctr"/>
+          <a:lstStyle/>
+          <a:p>
+            <a:pPr algn="ctr"/>
+            <a:r>
+              <a:rPr lang="en-GB" sz="1400" dirty="0">
+                <a:solidFill>
+                  <a:schemeClr val="tx1"/>
+                </a:solidFill>
+              </a:rPr>
+              <a:t>       </a:t>
+            </a:r>
+          </a:p>
+          <a:p>
+            <a:pPr algn="ctr"/>
+            <a:endParaRPr lang="en-GB" sz="1400" dirty="0">
+              <a:solidFill>
+                <a:schemeClr val="tx1"/>
+              </a:solidFill>
+            </a:endParaRPr>
+          </a:p>
+          <a:p>
+            <a:pPr algn="ctr"/>
+            <a:endParaRPr lang="en-GB" sz="1400" dirty="0">
+              <a:solidFill>
+                <a:schemeClr val="tx1"/>
+              </a:solidFill>
+            </a:endParaRPr>
+          </a:p>
+          <a:p>
+            <a:pPr algn="ctr"/>
+            <a:endParaRPr lang="en-GB" sz="1400" dirty="0">
+              <a:solidFill>
+                <a:schemeClr val="tx1"/>
+              </a:solidFill>
+            </a:endParaRPr>
+          </a:p>
+        </p:txBody>
+      </p:sp>
+      <p:sp>
+        <p:nvSpPr>
+          <p:cNvPr id="5" name="Oval 4">
+            <a:extLst>
+              <a:ext uri="{FF2B5EF4-FFF2-40B4-BE49-F238E27FC236}">
+                <a16:creationId xmlns:a16="http://schemas.microsoft.com/office/drawing/2014/main" id="{B3EDD419-07D3-2EFF-CC6A-395ECB95A499}"/>
+              </a:ext>
+            </a:extLst>
+          </p:cNvPr>
+          <p:cNvSpPr/>
+          <p:nvPr/>
+        </p:nvSpPr>
+        <p:spPr>
+          <a:xfrm>
+            <a:off x="8323632" y="4775918"/>
+            <a:ext cx="1100667" cy="1077218"/>
+          </a:xfrm>
+          <a:prstGeom prst="ellipse">
+            <a:avLst/>
+          </a:prstGeom>
+          <a:noFill/>
+          <a:ln>
+            <a:solidFill>
+              <a:schemeClr val="tx1"/>
+            </a:solidFill>
+          </a:ln>
+        </p:spPr>
+        <p:style>
+          <a:lnRef idx="2">
+            <a:schemeClr val="accent1">
+              <a:shade val="50000"/>
+            </a:schemeClr>
+          </a:lnRef>
+          <a:fillRef idx="1">
+            <a:schemeClr val="accent1"/>
+          </a:fillRef>
+          <a:effectRef idx="0">
+            <a:schemeClr val="accent1"/>
+          </a:effectRef>
+          <a:fontRef idx="minor">
+            <a:schemeClr val="lt1"/>
+          </a:fontRef>
+        </p:style>
+        <p:txBody>
+          <a:bodyPr rtlCol="0" anchor="ctr"/>
+          <a:lstStyle/>
+          <a:p>
+            <a:r>
+              <a:rPr lang="en-GB" sz="1400" dirty="0">
+                <a:solidFill>
+                  <a:schemeClr val="tx1"/>
+                </a:solidFill>
+              </a:rPr>
+              <a:t>Q10               </a:t>
+            </a:r>
+          </a:p>
+          <a:p>
+            <a:pPr algn="ctr"/>
+            <a:endParaRPr lang="en-GB" sz="1400" dirty="0">
+              <a:solidFill>
+                <a:schemeClr val="tx1"/>
+              </a:solidFill>
+            </a:endParaRPr>
+          </a:p>
+          <a:p>
+            <a:pPr algn="ctr"/>
+            <a:endParaRPr lang="en-GB" sz="1400" dirty="0">
+              <a:solidFill>
+                <a:schemeClr val="tx1"/>
+              </a:solidFill>
+            </a:endParaRPr>
+          </a:p>
+        </p:txBody>
+      </p:sp>
+      <p:sp>
+        <p:nvSpPr>
+          <p:cNvPr id="11" name="Oval 10">
+            <a:extLst>
+              <a:ext uri="{FF2B5EF4-FFF2-40B4-BE49-F238E27FC236}">
+                <a16:creationId xmlns:a16="http://schemas.microsoft.com/office/drawing/2014/main" id="{9CB37257-BB33-1212-6C47-6247F7B2D38B}"/>
+              </a:ext>
+            </a:extLst>
+          </p:cNvPr>
+          <p:cNvSpPr/>
+          <p:nvPr/>
+        </p:nvSpPr>
+        <p:spPr>
+          <a:xfrm>
+            <a:off x="8680981" y="5481821"/>
+            <a:ext cx="1100667" cy="1077218"/>
+          </a:xfrm>
+          <a:prstGeom prst="ellipse">
+            <a:avLst/>
+          </a:prstGeom>
+          <a:noFill/>
+          <a:ln>
+            <a:solidFill>
+              <a:schemeClr val="tx1"/>
+            </a:solidFill>
+          </a:ln>
+        </p:spPr>
+        <p:style>
+          <a:lnRef idx="2">
+            <a:schemeClr val="accent1">
+              <a:shade val="50000"/>
+            </a:schemeClr>
+          </a:lnRef>
+          <a:fillRef idx="1">
+            <a:schemeClr val="accent1"/>
+          </a:fillRef>
+          <a:effectRef idx="0">
+            <a:schemeClr val="accent1"/>
+          </a:effectRef>
+          <a:fontRef idx="minor">
+            <a:schemeClr val="lt1"/>
+          </a:fontRef>
+        </p:style>
+        <p:txBody>
+          <a:bodyPr rtlCol="0" anchor="ctr"/>
+          <a:lstStyle/>
+          <a:p>
+            <a:pPr algn="ctr"/>
+            <a:endParaRPr lang="en-GB" sz="1400" dirty="0">
+              <a:solidFill>
+                <a:schemeClr val="tx1"/>
+              </a:solidFill>
+            </a:endParaRPr>
+          </a:p>
+          <a:p>
+            <a:pPr algn="ctr"/>
+            <a:endParaRPr lang="en-GB" sz="1400" dirty="0">
+              <a:solidFill>
+                <a:schemeClr val="tx1"/>
+              </a:solidFill>
+            </a:endParaRPr>
+          </a:p>
+          <a:p>
+            <a:pPr algn="ctr"/>
+            <a:endParaRPr lang="en-GB" sz="1400" dirty="0">
+              <a:solidFill>
+                <a:schemeClr val="tx1"/>
+              </a:solidFill>
+            </a:endParaRPr>
+          </a:p>
+          <a:p>
+            <a:pPr algn="ctr"/>
+            <a:r>
+              <a:rPr lang="en-GB" sz="1400" dirty="0">
+                <a:solidFill>
+                  <a:schemeClr val="tx1"/>
+                </a:solidFill>
+              </a:rPr>
+              <a:t>MR1</a:t>
+            </a:r>
+          </a:p>
+        </p:txBody>
+      </p:sp>
+      <p:sp>
+        <p:nvSpPr>
+          <p:cNvPr id="14" name="TextBox 13">
+            <a:extLst>
+              <a:ext uri="{FF2B5EF4-FFF2-40B4-BE49-F238E27FC236}">
+                <a16:creationId xmlns:a16="http://schemas.microsoft.com/office/drawing/2014/main" id="{E93CDBBB-84AB-FC8E-687F-5D2560A5DE8B}"/>
               </a:ext>
             </a:extLst>
           </p:cNvPr>
@@ -13453,7 +13448,7 @@
         </p:nvSpPr>
         <p:spPr>
           <a:xfrm>
-            <a:off x="9210111" y="5282434"/>
+            <a:off x="9268368" y="5353019"/>
             <a:ext cx="690034" cy="307777"/>
           </a:xfrm>
           <a:prstGeom prst="rect">
@@ -13469,12 +13464,8 @@
           <a:p>
             <a:pPr algn="r"/>
             <a:r>
-              <a:rPr lang="en-GB" sz="1400" dirty="0">
-                <a:solidFill>
-                  <a:schemeClr val="tx1"/>
-                </a:solidFill>
-              </a:rPr>
-              <a:t>ML2</a:t>
+              <a:rPr lang="en-GB" sz="1400" dirty="0"/>
+              <a:t>MR2</a:t>
             </a:r>
           </a:p>
         </p:txBody>
@@ -13509,12 +13500,42 @@
           <a:chExt cx="0" cy="0"/>
         </a:xfrm>
       </p:grpSpPr>
+      <p:pic>
+        <p:nvPicPr>
+          <p:cNvPr id="4" name="Picture 3">
+            <a:extLst>
+              <a:ext uri="{FF2B5EF4-FFF2-40B4-BE49-F238E27FC236}">
+                <a16:creationId xmlns:a16="http://schemas.microsoft.com/office/drawing/2014/main" id="{2DE562D9-C9F0-1B44-B7C1-C8F86E72BDBA}"/>
+              </a:ext>
+            </a:extLst>
+          </p:cNvPr>
+          <p:cNvPicPr>
+            <a:picLocks noChangeAspect="1"/>
+          </p:cNvPicPr>
+          <p:nvPr/>
+        </p:nvPicPr>
+        <p:blipFill>
+          <a:blip r:embed="rId2"/>
+          <a:stretch>
+            <a:fillRect/>
+          </a:stretch>
+        </p:blipFill>
+        <p:spPr>
+          <a:xfrm>
+            <a:off x="3333225" y="424695"/>
+            <a:ext cx="8783276" cy="3448531"/>
+          </a:xfrm>
+          <a:prstGeom prst="rect">
+            <a:avLst/>
+          </a:prstGeom>
+        </p:spPr>
+      </p:pic>
       <p:sp>
         <p:nvSpPr>
-          <p:cNvPr id="22" name="Oval 21">
-            <a:extLst>
-              <a:ext uri="{FF2B5EF4-FFF2-40B4-BE49-F238E27FC236}">
-                <a16:creationId xmlns:a16="http://schemas.microsoft.com/office/drawing/2014/main" id="{595B87A1-E924-48DE-996A-51BAC263E252}"/>
+          <p:cNvPr id="46" name="Oval 45">
+            <a:extLst>
+              <a:ext uri="{FF2B5EF4-FFF2-40B4-BE49-F238E27FC236}">
+                <a16:creationId xmlns:a16="http://schemas.microsoft.com/office/drawing/2014/main" id="{E47AEFE7-6F2B-46B7-8B1D-D31EEE418A50}"/>
               </a:ext>
             </a:extLst>
           </p:cNvPr>
@@ -13523,7 +13544,7 @@
         </p:nvSpPr>
         <p:spPr>
           <a:xfrm>
-            <a:off x="5015033" y="5169127"/>
+            <a:off x="2295544" y="4506715"/>
             <a:ext cx="1100667" cy="1077218"/>
           </a:xfrm>
           <a:prstGeom prst="ellipse">
@@ -13559,11 +13580,14 @@
           <a:lstStyle/>
           <a:p>
             <a:pPr algn="ctr"/>
-            <a:endParaRPr lang="en-GB" sz="1400" dirty="0">
-              <a:solidFill>
-                <a:schemeClr val="tx1"/>
-              </a:solidFill>
-            </a:endParaRPr>
+            <a:r>
+              <a:rPr lang="en-GB" sz="1400" dirty="0">
+                <a:solidFill>
+                  <a:schemeClr val="tx1"/>
+                </a:solidFill>
+              </a:rPr>
+              <a:t>       </a:t>
+            </a:r>
           </a:p>
           <a:p>
             <a:pPr algn="ctr"/>
@@ -13583,25 +13607,360 @@
           </a:p>
           <a:p>
             <a:pPr algn="ctr"/>
-            <a:r>
-              <a:rPr lang="en-GB" sz="1400" dirty="0">
-                <a:solidFill>
-                  <a:schemeClr val="bg1">
-                    <a:lumMod val="85000"/>
-                  </a:schemeClr>
-                </a:solidFill>
-              </a:rPr>
-              <a:t>ML1</a:t>
-            </a:r>
+            <a:endParaRPr lang="en-GB" sz="1400" dirty="0">
+              <a:solidFill>
+                <a:schemeClr val="tx1"/>
+              </a:solidFill>
+            </a:endParaRPr>
           </a:p>
         </p:txBody>
       </p:sp>
       <p:sp>
         <p:nvSpPr>
-          <p:cNvPr id="46" name="Oval 45">
-            <a:extLst>
-              <a:ext uri="{FF2B5EF4-FFF2-40B4-BE49-F238E27FC236}">
-                <a16:creationId xmlns:a16="http://schemas.microsoft.com/office/drawing/2014/main" id="{E47AEFE7-6F2B-46B7-8B1D-D31EEE418A50}"/>
+          <p:cNvPr id="12" name="TextBox 11">
+            <a:extLst>
+              <a:ext uri="{FF2B5EF4-FFF2-40B4-BE49-F238E27FC236}">
+                <a16:creationId xmlns:a16="http://schemas.microsoft.com/office/drawing/2014/main" id="{02B9EF90-F348-4C67-8F54-FA122021CEA6}"/>
+              </a:ext>
+            </a:extLst>
+          </p:cNvPr>
+          <p:cNvSpPr txBox="1"/>
+          <p:nvPr/>
+        </p:nvSpPr>
+        <p:spPr>
+          <a:xfrm>
+            <a:off x="75499" y="-25167"/>
+            <a:ext cx="8010168" cy="461665"/>
+          </a:xfrm>
+          <a:prstGeom prst="rect">
+            <a:avLst/>
+          </a:prstGeom>
+          <a:noFill/>
+        </p:spPr>
+        <p:txBody>
+          <a:bodyPr wrap="square" rtlCol="0">
+            <a:spAutoFit/>
+          </a:bodyPr>
+          <a:lstStyle/>
+          <a:p>
+            <a:r>
+              <a:rPr lang="en-GB" sz="2400" u="sng" dirty="0">
+                <a:solidFill>
+                  <a:srgbClr val="A41AE4"/>
+                </a:solidFill>
+              </a:rPr>
+              <a:t>RABBIT HOLE: STRUCTURE MATRIX vs PATTERN MATRIX</a:t>
+            </a:r>
+          </a:p>
+        </p:txBody>
+      </p:sp>
+      <p:cxnSp>
+        <p:nvCxnSpPr>
+          <p:cNvPr id="7" name="Straight Arrow Connector 6">
+            <a:extLst>
+              <a:ext uri="{FF2B5EF4-FFF2-40B4-BE49-F238E27FC236}">
+                <a16:creationId xmlns:a16="http://schemas.microsoft.com/office/drawing/2014/main" id="{B614BF2E-BBAA-46A8-BF78-EC817E3D2D33}"/>
+              </a:ext>
+            </a:extLst>
+          </p:cNvPr>
+          <p:cNvCxnSpPr>
+            <a:cxnSpLocks/>
+          </p:cNvCxnSpPr>
+          <p:nvPr/>
+        </p:nvCxnSpPr>
+        <p:spPr>
+          <a:xfrm flipH="1">
+            <a:off x="2477408" y="3826919"/>
+            <a:ext cx="1622644" cy="1426568"/>
+          </a:xfrm>
+          <a:prstGeom prst="straightConnector1">
+            <a:avLst/>
+          </a:prstGeom>
+          <a:ln w="12700">
+            <a:tailEnd type="triangle"/>
+          </a:ln>
+        </p:spPr>
+        <p:style>
+          <a:lnRef idx="1">
+            <a:schemeClr val="accent6"/>
+          </a:lnRef>
+          <a:fillRef idx="0">
+            <a:schemeClr val="accent6"/>
+          </a:fillRef>
+          <a:effectRef idx="0">
+            <a:schemeClr val="accent6"/>
+          </a:effectRef>
+          <a:fontRef idx="minor">
+            <a:schemeClr val="tx1"/>
+          </a:fontRef>
+        </p:style>
+      </p:cxnSp>
+      <p:cxnSp>
+        <p:nvCxnSpPr>
+          <p:cNvPr id="33" name="Straight Arrow Connector 32">
+            <a:extLst>
+              <a:ext uri="{FF2B5EF4-FFF2-40B4-BE49-F238E27FC236}">
+                <a16:creationId xmlns:a16="http://schemas.microsoft.com/office/drawing/2014/main" id="{7FDDBA15-E3CA-42A3-8EC0-CE70142CF45B}"/>
+              </a:ext>
+            </a:extLst>
+          </p:cNvPr>
+          <p:cNvCxnSpPr>
+            <a:cxnSpLocks/>
+          </p:cNvCxnSpPr>
+          <p:nvPr/>
+        </p:nvCxnSpPr>
+        <p:spPr>
+          <a:xfrm>
+            <a:off x="4833953" y="3826919"/>
+            <a:ext cx="645073" cy="1175530"/>
+          </a:xfrm>
+          <a:prstGeom prst="straightConnector1">
+            <a:avLst/>
+          </a:prstGeom>
+          <a:ln w="12700">
+            <a:tailEnd type="triangle"/>
+          </a:ln>
+        </p:spPr>
+        <p:style>
+          <a:lnRef idx="1">
+            <a:schemeClr val="accent6"/>
+          </a:lnRef>
+          <a:fillRef idx="0">
+            <a:schemeClr val="accent6"/>
+          </a:fillRef>
+          <a:effectRef idx="0">
+            <a:schemeClr val="accent6"/>
+          </a:effectRef>
+          <a:fontRef idx="minor">
+            <a:schemeClr val="tx1"/>
+          </a:fontRef>
+        </p:style>
+      </p:cxnSp>
+      <p:sp>
+        <p:nvSpPr>
+          <p:cNvPr id="37" name="TextBox 36">
+            <a:extLst>
+              <a:ext uri="{FF2B5EF4-FFF2-40B4-BE49-F238E27FC236}">
+                <a16:creationId xmlns:a16="http://schemas.microsoft.com/office/drawing/2014/main" id="{0AB66053-05F8-46DC-90F1-7AE959335435}"/>
+              </a:ext>
+            </a:extLst>
+          </p:cNvPr>
+          <p:cNvSpPr txBox="1"/>
+          <p:nvPr/>
+        </p:nvSpPr>
+        <p:spPr>
+          <a:xfrm>
+            <a:off x="5607386" y="1090455"/>
+            <a:ext cx="6378201" cy="3293209"/>
+          </a:xfrm>
+          <a:prstGeom prst="rect">
+            <a:avLst/>
+          </a:prstGeom>
+          <a:noFill/>
+        </p:spPr>
+        <p:txBody>
+          <a:bodyPr wrap="square" rtlCol="0">
+            <a:spAutoFit/>
+          </a:bodyPr>
+          <a:lstStyle/>
+          <a:p>
+            <a:r>
+              <a:rPr lang="en-GB" sz="1600" dirty="0">
+                <a:solidFill>
+                  <a:srgbClr val="A41AE4"/>
+                </a:solidFill>
+              </a:rPr>
+              <a:t>When an oblique rotation is used, factors can be correlated. Therefore to get the </a:t>
+            </a:r>
+            <a:r>
+              <a:rPr lang="en-GB" sz="1600" i="1" dirty="0">
+                <a:solidFill>
+                  <a:srgbClr val="A41AE4"/>
+                </a:solidFill>
+              </a:rPr>
+              <a:t>unique </a:t>
+            </a:r>
+            <a:r>
+              <a:rPr lang="en-GB" sz="1600" dirty="0">
+                <a:solidFill>
+                  <a:srgbClr val="A41AE4"/>
+                </a:solidFill>
+              </a:rPr>
+              <a:t>association between item and factors, we use the “pattern matrix”. This is what </a:t>
+            </a:r>
+            <a:r>
+              <a:rPr lang="en-GB" sz="1600" dirty="0">
+                <a:solidFill>
+                  <a:srgbClr val="A41AE4"/>
+                </a:solidFill>
+                <a:latin typeface="Courier New" panose="02070309020205020404" pitchFamily="49" charset="0"/>
+                <a:cs typeface="Courier New" panose="02070309020205020404" pitchFamily="49" charset="0"/>
+              </a:rPr>
+              <a:t>fa()</a:t>
+            </a:r>
+            <a:r>
+              <a:rPr lang="en-GB" sz="1600" dirty="0">
+                <a:solidFill>
+                  <a:srgbClr val="A41AE4"/>
+                </a:solidFill>
+              </a:rPr>
+              <a:t> prints by default. </a:t>
+            </a:r>
+            <a:br>
+              <a:rPr lang="en-GB" sz="1600" dirty="0">
+                <a:solidFill>
+                  <a:srgbClr val="A41AE4"/>
+                </a:solidFill>
+              </a:rPr>
+            </a:br>
+            <a:br>
+              <a:rPr lang="en-GB" sz="1600" dirty="0">
+                <a:solidFill>
+                  <a:srgbClr val="A41AE4"/>
+                </a:solidFill>
+              </a:rPr>
+            </a:br>
+            <a:r>
+              <a:rPr lang="en-GB" sz="1600" dirty="0">
+                <a:solidFill>
+                  <a:srgbClr val="A41AE4"/>
+                </a:solidFill>
+              </a:rPr>
+              <a:t>The loadings in the pattern matrix are similar to regression weights from a model of </a:t>
+            </a:r>
+            <a:r>
+              <a:rPr lang="en-GB" sz="1600" dirty="0">
+                <a:solidFill>
+                  <a:srgbClr val="A41AE4"/>
+                </a:solidFill>
+                <a:latin typeface="Courier New" panose="02070309020205020404" pitchFamily="49" charset="0"/>
+                <a:cs typeface="Courier New" panose="02070309020205020404" pitchFamily="49" charset="0"/>
+              </a:rPr>
+              <a:t>item ~ factor1 + factor2</a:t>
+            </a:r>
+            <a:r>
+              <a:rPr lang="en-GB" sz="1600" dirty="0">
+                <a:solidFill>
+                  <a:srgbClr val="A41AE4"/>
+                </a:solidFill>
+              </a:rPr>
+              <a:t>. </a:t>
+            </a:r>
+          </a:p>
+          <a:p>
+            <a:endParaRPr lang="en-GB" sz="1600" dirty="0">
+              <a:solidFill>
+                <a:srgbClr val="A41AE4"/>
+              </a:solidFill>
+            </a:endParaRPr>
+          </a:p>
+          <a:p>
+            <a:r>
+              <a:rPr lang="en-GB" sz="1600" dirty="0">
+                <a:solidFill>
+                  <a:srgbClr val="A41AE4"/>
+                </a:solidFill>
+              </a:rPr>
+              <a:t>Behind the scenes, there is also the “Structure matrix” which contains the correlations </a:t>
+            </a:r>
+            <a:r>
+              <a:rPr lang="en-GB" sz="1600" dirty="0" err="1">
+                <a:solidFill>
+                  <a:srgbClr val="A41AE4"/>
+                </a:solidFill>
+                <a:latin typeface="Courier New" panose="02070309020205020404" pitchFamily="49" charset="0"/>
+                <a:cs typeface="Courier New" panose="02070309020205020404" pitchFamily="49" charset="0"/>
+              </a:rPr>
+              <a:t>cor</a:t>
+            </a:r>
+            <a:r>
+              <a:rPr lang="en-GB" sz="1600" dirty="0">
+                <a:solidFill>
+                  <a:srgbClr val="A41AE4"/>
+                </a:solidFill>
+                <a:latin typeface="Courier New" panose="02070309020205020404" pitchFamily="49" charset="0"/>
+                <a:cs typeface="Courier New" panose="02070309020205020404" pitchFamily="49" charset="0"/>
+              </a:rPr>
+              <a:t>(item, factor1) </a:t>
+            </a:r>
+            <a:r>
+              <a:rPr lang="en-GB" sz="1600" dirty="0">
+                <a:solidFill>
+                  <a:srgbClr val="A41AE4"/>
+                </a:solidFill>
+              </a:rPr>
+              <a:t>and </a:t>
+            </a:r>
+            <a:r>
+              <a:rPr lang="en-GB" sz="1600" dirty="0" err="1">
+                <a:solidFill>
+                  <a:srgbClr val="A41AE4"/>
+                </a:solidFill>
+                <a:latin typeface="Courier New" panose="02070309020205020404" pitchFamily="49" charset="0"/>
+                <a:cs typeface="Courier New" panose="02070309020205020404" pitchFamily="49" charset="0"/>
+              </a:rPr>
+              <a:t>cor</a:t>
+            </a:r>
+            <a:r>
+              <a:rPr lang="en-GB" sz="1600" dirty="0">
+                <a:solidFill>
+                  <a:srgbClr val="A41AE4"/>
+                </a:solidFill>
+                <a:latin typeface="Courier New" panose="02070309020205020404" pitchFamily="49" charset="0"/>
+                <a:cs typeface="Courier New" panose="02070309020205020404" pitchFamily="49" charset="0"/>
+              </a:rPr>
+              <a:t>(item, factor2)</a:t>
+            </a:r>
+            <a:r>
+              <a:rPr lang="en-GB" sz="1600" dirty="0">
+                <a:solidFill>
+                  <a:srgbClr val="A41AE4"/>
+                </a:solidFill>
+              </a:rPr>
+              <a:t>. </a:t>
+            </a:r>
+          </a:p>
+          <a:p>
+            <a:endParaRPr lang="en-GB" sz="1600" dirty="0">
+              <a:solidFill>
+                <a:srgbClr val="A41AE4"/>
+              </a:solidFill>
+            </a:endParaRPr>
+          </a:p>
+          <a:p>
+            <a:r>
+              <a:rPr lang="en-GB" sz="1600" dirty="0">
+                <a:solidFill>
+                  <a:srgbClr val="A41AE4"/>
+                </a:solidFill>
+              </a:rPr>
+              <a:t>If the factors are </a:t>
+            </a:r>
+            <a:r>
+              <a:rPr lang="en-GB" sz="1600" b="1" dirty="0">
+                <a:solidFill>
+                  <a:srgbClr val="A41AE4"/>
+                </a:solidFill>
+              </a:rPr>
+              <a:t>not</a:t>
+            </a:r>
+            <a:r>
+              <a:rPr lang="en-GB" sz="1600" dirty="0">
+                <a:solidFill>
+                  <a:srgbClr val="A41AE4"/>
+                </a:solidFill>
+              </a:rPr>
+              <a:t> correlated (by definition they are uncorrelated when no rotation or an orthogonal rotation is used), then pattern matrix and structure matrix are identical. </a:t>
+            </a:r>
+          </a:p>
+        </p:txBody>
+      </p:sp>
+      <p:sp>
+        <p:nvSpPr>
+          <p:cNvPr id="45" name="Oval 44">
+            <a:extLst>
+              <a:ext uri="{FF2B5EF4-FFF2-40B4-BE49-F238E27FC236}">
+                <a16:creationId xmlns:a16="http://schemas.microsoft.com/office/drawing/2014/main" id="{0AB6BDCA-1687-4B9E-B338-D36D15256A4E}"/>
               </a:ext>
             </a:extLst>
           </p:cNvPr>
@@ -13610,7 +13969,280 @@
         </p:nvSpPr>
         <p:spPr>
           <a:xfrm>
-            <a:off x="2295544" y="4506715"/>
+            <a:off x="1781516" y="4290527"/>
+            <a:ext cx="1100667" cy="1077218"/>
+          </a:xfrm>
+          <a:prstGeom prst="ellipse">
+            <a:avLst/>
+          </a:prstGeom>
+          <a:noFill/>
+          <a:ln>
+            <a:solidFill>
+              <a:schemeClr val="tx1"/>
+            </a:solidFill>
+          </a:ln>
+        </p:spPr>
+        <p:style>
+          <a:lnRef idx="2">
+            <a:schemeClr val="accent1">
+              <a:shade val="50000"/>
+            </a:schemeClr>
+          </a:lnRef>
+          <a:fillRef idx="1">
+            <a:schemeClr val="accent1"/>
+          </a:fillRef>
+          <a:effectRef idx="0">
+            <a:schemeClr val="accent1"/>
+          </a:effectRef>
+          <a:fontRef idx="minor">
+            <a:schemeClr val="lt1"/>
+          </a:fontRef>
+        </p:style>
+        <p:txBody>
+          <a:bodyPr rtlCol="0" anchor="ctr"/>
+          <a:lstStyle/>
+          <a:p>
+            <a:r>
+              <a:rPr lang="en-GB" sz="1400" dirty="0">
+                <a:solidFill>
+                  <a:schemeClr val="tx1"/>
+                </a:solidFill>
+              </a:rPr>
+              <a:t>Q10               </a:t>
+            </a:r>
+          </a:p>
+          <a:p>
+            <a:pPr algn="ctr"/>
+            <a:endParaRPr lang="en-GB" sz="1400" dirty="0">
+              <a:solidFill>
+                <a:schemeClr val="tx1"/>
+              </a:solidFill>
+            </a:endParaRPr>
+          </a:p>
+          <a:p>
+            <a:pPr algn="ctr"/>
+            <a:endParaRPr lang="en-GB" sz="1400" dirty="0">
+              <a:solidFill>
+                <a:schemeClr val="tx1"/>
+              </a:solidFill>
+            </a:endParaRPr>
+          </a:p>
+        </p:txBody>
+      </p:sp>
+      <p:sp>
+        <p:nvSpPr>
+          <p:cNvPr id="47" name="Oval 46">
+            <a:extLst>
+              <a:ext uri="{FF2B5EF4-FFF2-40B4-BE49-F238E27FC236}">
+                <a16:creationId xmlns:a16="http://schemas.microsoft.com/office/drawing/2014/main" id="{67092F04-50D0-4C4A-AD62-DD1E545AE9DF}"/>
+              </a:ext>
+            </a:extLst>
+          </p:cNvPr>
+          <p:cNvSpPr/>
+          <p:nvPr/>
+        </p:nvSpPr>
+        <p:spPr>
+          <a:xfrm>
+            <a:off x="2138865" y="4996430"/>
+            <a:ext cx="1100667" cy="1077218"/>
+          </a:xfrm>
+          <a:prstGeom prst="ellipse">
+            <a:avLst/>
+          </a:prstGeom>
+          <a:noFill/>
+          <a:ln>
+            <a:solidFill>
+              <a:schemeClr val="tx1"/>
+            </a:solidFill>
+          </a:ln>
+        </p:spPr>
+        <p:style>
+          <a:lnRef idx="2">
+            <a:schemeClr val="accent1">
+              <a:shade val="50000"/>
+            </a:schemeClr>
+          </a:lnRef>
+          <a:fillRef idx="1">
+            <a:schemeClr val="accent1"/>
+          </a:fillRef>
+          <a:effectRef idx="0">
+            <a:schemeClr val="accent1"/>
+          </a:effectRef>
+          <a:fontRef idx="minor">
+            <a:schemeClr val="lt1"/>
+          </a:fontRef>
+        </p:style>
+        <p:txBody>
+          <a:bodyPr rtlCol="0" anchor="ctr"/>
+          <a:lstStyle/>
+          <a:p>
+            <a:pPr algn="ctr"/>
+            <a:endParaRPr lang="en-GB" sz="1400" dirty="0">
+              <a:solidFill>
+                <a:schemeClr val="tx1"/>
+              </a:solidFill>
+            </a:endParaRPr>
+          </a:p>
+          <a:p>
+            <a:pPr algn="ctr"/>
+            <a:endParaRPr lang="en-GB" sz="1400" dirty="0">
+              <a:solidFill>
+                <a:schemeClr val="tx1"/>
+              </a:solidFill>
+            </a:endParaRPr>
+          </a:p>
+          <a:p>
+            <a:pPr algn="ctr"/>
+            <a:endParaRPr lang="en-GB" sz="1400" dirty="0">
+              <a:solidFill>
+                <a:schemeClr val="tx1"/>
+              </a:solidFill>
+            </a:endParaRPr>
+          </a:p>
+          <a:p>
+            <a:pPr algn="ctr"/>
+            <a:r>
+              <a:rPr lang="en-GB" sz="1400" dirty="0">
+                <a:solidFill>
+                  <a:schemeClr val="tx1"/>
+                </a:solidFill>
+              </a:rPr>
+              <a:t>MR1</a:t>
+            </a:r>
+          </a:p>
+        </p:txBody>
+      </p:sp>
+      <p:sp>
+        <p:nvSpPr>
+          <p:cNvPr id="48" name="TextBox 47">
+            <a:extLst>
+              <a:ext uri="{FF2B5EF4-FFF2-40B4-BE49-F238E27FC236}">
+                <a16:creationId xmlns:a16="http://schemas.microsoft.com/office/drawing/2014/main" id="{09FE0C98-AE7B-4971-8B4E-CC57DDB1309A}"/>
+              </a:ext>
+            </a:extLst>
+          </p:cNvPr>
+          <p:cNvSpPr txBox="1"/>
+          <p:nvPr/>
+        </p:nvSpPr>
+        <p:spPr>
+          <a:xfrm>
+            <a:off x="2726252" y="4867628"/>
+            <a:ext cx="690034" cy="307777"/>
+          </a:xfrm>
+          <a:prstGeom prst="rect">
+            <a:avLst/>
+          </a:prstGeom>
+          <a:noFill/>
+        </p:spPr>
+        <p:txBody>
+          <a:bodyPr wrap="square">
+            <a:spAutoFit/>
+          </a:bodyPr>
+          <a:lstStyle/>
+          <a:p>
+            <a:pPr algn="r"/>
+            <a:r>
+              <a:rPr lang="en-GB" sz="1400" dirty="0">
+                <a:solidFill>
+                  <a:schemeClr val="bg1">
+                    <a:lumMod val="85000"/>
+                  </a:schemeClr>
+                </a:solidFill>
+              </a:rPr>
+              <a:t>MR2</a:t>
+            </a:r>
+          </a:p>
+        </p:txBody>
+      </p:sp>
+      <p:sp>
+        <p:nvSpPr>
+          <p:cNvPr id="8" name="Oval 7">
+            <a:extLst>
+              <a:ext uri="{FF2B5EF4-FFF2-40B4-BE49-F238E27FC236}">
+                <a16:creationId xmlns:a16="http://schemas.microsoft.com/office/drawing/2014/main" id="{D6F00C8C-7F9D-4755-EF7C-9E79EF6C65D5}"/>
+              </a:ext>
+            </a:extLst>
+          </p:cNvPr>
+          <p:cNvSpPr/>
+          <p:nvPr/>
+        </p:nvSpPr>
+        <p:spPr>
+          <a:xfrm>
+            <a:off x="4606010" y="4323088"/>
+            <a:ext cx="1100667" cy="1077218"/>
+          </a:xfrm>
+          <a:prstGeom prst="ellipse">
+            <a:avLst/>
+          </a:prstGeom>
+          <a:noFill/>
+          <a:ln>
+            <a:solidFill>
+              <a:schemeClr val="tx1"/>
+            </a:solidFill>
+          </a:ln>
+        </p:spPr>
+        <p:style>
+          <a:lnRef idx="2">
+            <a:schemeClr val="accent1">
+              <a:shade val="50000"/>
+            </a:schemeClr>
+          </a:lnRef>
+          <a:fillRef idx="1">
+            <a:schemeClr val="accent1"/>
+          </a:fillRef>
+          <a:effectRef idx="0">
+            <a:schemeClr val="accent1"/>
+          </a:effectRef>
+          <a:fontRef idx="minor">
+            <a:schemeClr val="lt1"/>
+          </a:fontRef>
+        </p:style>
+        <p:txBody>
+          <a:bodyPr rtlCol="0" anchor="ctr"/>
+          <a:lstStyle/>
+          <a:p>
+            <a:r>
+              <a:rPr lang="en-GB" sz="1400" dirty="0">
+                <a:solidFill>
+                  <a:schemeClr val="tx1"/>
+                </a:solidFill>
+              </a:rPr>
+              <a:t>Q10               </a:t>
+            </a:r>
+          </a:p>
+          <a:p>
+            <a:pPr algn="ctr"/>
+            <a:endParaRPr lang="en-GB" sz="1400" dirty="0">
+              <a:solidFill>
+                <a:schemeClr val="tx1"/>
+              </a:solidFill>
+            </a:endParaRPr>
+          </a:p>
+          <a:p>
+            <a:pPr algn="ctr"/>
+            <a:endParaRPr lang="en-GB" sz="1400" dirty="0">
+              <a:solidFill>
+                <a:schemeClr val="tx1"/>
+              </a:solidFill>
+            </a:endParaRPr>
+          </a:p>
+        </p:txBody>
+      </p:sp>
+      <p:sp>
+        <p:nvSpPr>
+          <p:cNvPr id="9" name="Oval 8">
+            <a:extLst>
+              <a:ext uri="{FF2B5EF4-FFF2-40B4-BE49-F238E27FC236}">
+                <a16:creationId xmlns:a16="http://schemas.microsoft.com/office/drawing/2014/main" id="{2E70944B-13B9-4ADA-2CFA-137623DB5E01}"/>
+              </a:ext>
+            </a:extLst>
+          </p:cNvPr>
+          <p:cNvSpPr/>
+          <p:nvPr/>
+        </p:nvSpPr>
+        <p:spPr>
+          <a:xfrm>
+            <a:off x="4963359" y="5028991"/>
             <a:ext cx="1100667" cy="1077218"/>
           </a:xfrm>
           <a:prstGeom prst="ellipse">
@@ -13646,14 +14278,11 @@
           <a:lstStyle/>
           <a:p>
             <a:pPr algn="ctr"/>
-            <a:r>
-              <a:rPr lang="en-GB" sz="1400" dirty="0">
-                <a:solidFill>
-                  <a:schemeClr val="tx1"/>
-                </a:solidFill>
-              </a:rPr>
-              <a:t>       </a:t>
-            </a:r>
+            <a:endParaRPr lang="en-GB" sz="1400" dirty="0">
+              <a:solidFill>
+                <a:schemeClr val="tx1"/>
+              </a:solidFill>
+            </a:endParaRPr>
           </a:p>
           <a:p>
             <a:pPr algn="ctr"/>
@@ -13673,50 +14302,25 @@
           </a:p>
           <a:p>
             <a:pPr algn="ctr"/>
-            <a:endParaRPr lang="en-GB" sz="1400" dirty="0">
-              <a:solidFill>
-                <a:schemeClr val="tx1"/>
-              </a:solidFill>
-            </a:endParaRPr>
+            <a:r>
+              <a:rPr lang="en-GB" sz="1400" dirty="0">
+                <a:solidFill>
+                  <a:schemeClr val="bg1">
+                    <a:lumMod val="85000"/>
+                  </a:schemeClr>
+                </a:solidFill>
+              </a:rPr>
+              <a:t>MR1</a:t>
+            </a:r>
           </a:p>
         </p:txBody>
       </p:sp>
-      <p:pic>
-        <p:nvPicPr>
-          <p:cNvPr id="3" name="Picture 2">
-            <a:extLst>
-              <a:ext uri="{FF2B5EF4-FFF2-40B4-BE49-F238E27FC236}">
-                <a16:creationId xmlns:a16="http://schemas.microsoft.com/office/drawing/2014/main" id="{7CFEF62B-2B33-47D0-AC16-DBB4E2F3D984}"/>
-              </a:ext>
-            </a:extLst>
-          </p:cNvPr>
-          <p:cNvPicPr>
-            <a:picLocks noChangeAspect="1"/>
-          </p:cNvPicPr>
-          <p:nvPr/>
-        </p:nvPicPr>
-        <p:blipFill>
-          <a:blip r:embed="rId2"/>
-          <a:stretch>
-            <a:fillRect/>
-          </a:stretch>
-        </p:blipFill>
-        <p:spPr>
-          <a:xfrm>
-            <a:off x="3292688" y="415779"/>
-            <a:ext cx="8116433" cy="3496163"/>
-          </a:xfrm>
-          <a:prstGeom prst="rect">
-            <a:avLst/>
-          </a:prstGeom>
-        </p:spPr>
-      </p:pic>
       <p:sp>
         <p:nvSpPr>
-          <p:cNvPr id="12" name="TextBox 11">
-            <a:extLst>
-              <a:ext uri="{FF2B5EF4-FFF2-40B4-BE49-F238E27FC236}">
-                <a16:creationId xmlns:a16="http://schemas.microsoft.com/office/drawing/2014/main" id="{02B9EF90-F348-4C67-8F54-FA122021CEA6}"/>
+          <p:cNvPr id="10" name="TextBox 9">
+            <a:extLst>
+              <a:ext uri="{FF2B5EF4-FFF2-40B4-BE49-F238E27FC236}">
+                <a16:creationId xmlns:a16="http://schemas.microsoft.com/office/drawing/2014/main" id="{06B22C54-B663-1BE7-CB87-D59B1290E1DC}"/>
               </a:ext>
             </a:extLst>
           </p:cNvPr>
@@ -13725,8 +14329,8 @@
         </p:nvSpPr>
         <p:spPr>
           <a:xfrm>
-            <a:off x="75499" y="-25167"/>
-            <a:ext cx="8010168" cy="461665"/>
+            <a:off x="5550746" y="4900189"/>
+            <a:ext cx="690034" cy="307777"/>
           </a:xfrm>
           <a:prstGeom prst="rect">
             <a:avLst/>
@@ -13734,329 +14338,25 @@
           <a:noFill/>
         </p:spPr>
         <p:txBody>
-          <a:bodyPr wrap="square" rtlCol="0">
+          <a:bodyPr wrap="square">
             <a:spAutoFit/>
           </a:bodyPr>
           <a:lstStyle/>
           <a:p>
-            <a:r>
-              <a:rPr lang="en-GB" sz="2400" u="sng" dirty="0">
-                <a:solidFill>
-                  <a:srgbClr val="A41AE4"/>
-                </a:solidFill>
-              </a:rPr>
-              <a:t>RABBIT HOLE: STRUCTURE MATRIX vs PATTERN MATRIX</a:t>
-            </a:r>
-          </a:p>
-        </p:txBody>
-      </p:sp>
-      <p:cxnSp>
-        <p:nvCxnSpPr>
-          <p:cNvPr id="7" name="Straight Arrow Connector 6">
-            <a:extLst>
-              <a:ext uri="{FF2B5EF4-FFF2-40B4-BE49-F238E27FC236}">
-                <a16:creationId xmlns:a16="http://schemas.microsoft.com/office/drawing/2014/main" id="{B614BF2E-BBAA-46A8-BF78-EC817E3D2D33}"/>
-              </a:ext>
-            </a:extLst>
-          </p:cNvPr>
-          <p:cNvCxnSpPr>
-            <a:cxnSpLocks/>
-          </p:cNvCxnSpPr>
-          <p:nvPr/>
-        </p:nvCxnSpPr>
-        <p:spPr>
-          <a:xfrm flipH="1">
-            <a:off x="2499852" y="3826919"/>
-            <a:ext cx="1600200" cy="1483306"/>
-          </a:xfrm>
-          <a:prstGeom prst="straightConnector1">
-            <a:avLst/>
-          </a:prstGeom>
-          <a:ln w="12700">
-            <a:tailEnd type="triangle"/>
-          </a:ln>
-        </p:spPr>
-        <p:style>
-          <a:lnRef idx="1">
-            <a:schemeClr val="accent6"/>
-          </a:lnRef>
-          <a:fillRef idx="0">
-            <a:schemeClr val="accent6"/>
-          </a:fillRef>
-          <a:effectRef idx="0">
-            <a:schemeClr val="accent6"/>
-          </a:effectRef>
-          <a:fontRef idx="minor">
-            <a:schemeClr val="tx1"/>
-          </a:fontRef>
-        </p:style>
-      </p:cxnSp>
-      <p:cxnSp>
-        <p:nvCxnSpPr>
-          <p:cNvPr id="33" name="Straight Arrow Connector 32">
-            <a:extLst>
-              <a:ext uri="{FF2B5EF4-FFF2-40B4-BE49-F238E27FC236}">
-                <a16:creationId xmlns:a16="http://schemas.microsoft.com/office/drawing/2014/main" id="{7FDDBA15-E3CA-42A3-8EC0-CE70142CF45B}"/>
-              </a:ext>
-            </a:extLst>
-          </p:cNvPr>
-          <p:cNvCxnSpPr>
-            <a:cxnSpLocks/>
-          </p:cNvCxnSpPr>
-          <p:nvPr/>
-        </p:nvCxnSpPr>
-        <p:spPr>
-          <a:xfrm>
-            <a:off x="4833953" y="3826919"/>
-            <a:ext cx="645073" cy="1175530"/>
-          </a:xfrm>
-          <a:prstGeom prst="straightConnector1">
-            <a:avLst/>
-          </a:prstGeom>
-          <a:ln w="12700">
-            <a:tailEnd type="triangle"/>
-          </a:ln>
-        </p:spPr>
-        <p:style>
-          <a:lnRef idx="1">
-            <a:schemeClr val="accent6"/>
-          </a:lnRef>
-          <a:fillRef idx="0">
-            <a:schemeClr val="accent6"/>
-          </a:fillRef>
-          <a:effectRef idx="0">
-            <a:schemeClr val="accent6"/>
-          </a:effectRef>
-          <a:fontRef idx="minor">
-            <a:schemeClr val="tx1"/>
-          </a:fontRef>
-        </p:style>
-      </p:cxnSp>
-      <p:sp>
-        <p:nvSpPr>
-          <p:cNvPr id="37" name="TextBox 36">
-            <a:extLst>
-              <a:ext uri="{FF2B5EF4-FFF2-40B4-BE49-F238E27FC236}">
-                <a16:creationId xmlns:a16="http://schemas.microsoft.com/office/drawing/2014/main" id="{0AB66053-05F8-46DC-90F1-7AE959335435}"/>
-              </a:ext>
-            </a:extLst>
-          </p:cNvPr>
-          <p:cNvSpPr txBox="1"/>
-          <p:nvPr/>
-        </p:nvSpPr>
-        <p:spPr>
-          <a:xfrm>
-            <a:off x="5607386" y="1090455"/>
-            <a:ext cx="6378201" cy="3293209"/>
-          </a:xfrm>
-          <a:prstGeom prst="rect">
-            <a:avLst/>
-          </a:prstGeom>
-          <a:noFill/>
-        </p:spPr>
-        <p:txBody>
-          <a:bodyPr wrap="square" rtlCol="0">
-            <a:spAutoFit/>
-          </a:bodyPr>
-          <a:lstStyle/>
-          <a:p>
-            <a:r>
-              <a:rPr lang="en-GB" sz="1600" dirty="0">
-                <a:solidFill>
-                  <a:srgbClr val="A41AE4"/>
-                </a:solidFill>
-              </a:rPr>
-              <a:t>When an oblique rotation is used, factors can be correlated. Therefore to get the </a:t>
-            </a:r>
-            <a:r>
-              <a:rPr lang="en-GB" sz="1600" i="1" dirty="0">
-                <a:solidFill>
-                  <a:srgbClr val="A41AE4"/>
-                </a:solidFill>
-              </a:rPr>
-              <a:t>unique </a:t>
-            </a:r>
-            <a:r>
-              <a:rPr lang="en-GB" sz="1600" dirty="0">
-                <a:solidFill>
-                  <a:srgbClr val="A41AE4"/>
-                </a:solidFill>
-              </a:rPr>
-              <a:t>association between item and factors, we use the “pattern matrix”. This is what </a:t>
-            </a:r>
-            <a:r>
-              <a:rPr lang="en-GB" sz="1600" dirty="0">
-                <a:solidFill>
-                  <a:srgbClr val="A41AE4"/>
-                </a:solidFill>
-                <a:latin typeface="Courier New" panose="02070309020205020404" pitchFamily="49" charset="0"/>
-                <a:cs typeface="Courier New" panose="02070309020205020404" pitchFamily="49" charset="0"/>
-              </a:rPr>
-              <a:t>fa()</a:t>
-            </a:r>
-            <a:r>
-              <a:rPr lang="en-GB" sz="1600" dirty="0">
-                <a:solidFill>
-                  <a:srgbClr val="A41AE4"/>
-                </a:solidFill>
-              </a:rPr>
-              <a:t> prints by default. </a:t>
-            </a:r>
-            <a:br>
-              <a:rPr lang="en-GB" sz="1600" dirty="0">
-                <a:solidFill>
-                  <a:srgbClr val="A41AE4"/>
-                </a:solidFill>
-              </a:rPr>
-            </a:br>
-            <a:br>
-              <a:rPr lang="en-GB" sz="1600" dirty="0">
-                <a:solidFill>
-                  <a:srgbClr val="A41AE4"/>
-                </a:solidFill>
-              </a:rPr>
-            </a:br>
-            <a:r>
-              <a:rPr lang="en-GB" sz="1600" dirty="0">
-                <a:solidFill>
-                  <a:srgbClr val="A41AE4"/>
-                </a:solidFill>
-              </a:rPr>
-              <a:t>The loadings in the pattern matrix are similar to regression weights from a model of </a:t>
-            </a:r>
-            <a:r>
-              <a:rPr lang="en-GB" sz="1600" dirty="0">
-                <a:solidFill>
-                  <a:srgbClr val="A41AE4"/>
-                </a:solidFill>
-                <a:latin typeface="Courier New" panose="02070309020205020404" pitchFamily="49" charset="0"/>
-                <a:cs typeface="Courier New" panose="02070309020205020404" pitchFamily="49" charset="0"/>
-              </a:rPr>
-              <a:t>item ~ factor1 + factor2</a:t>
-            </a:r>
-            <a:r>
-              <a:rPr lang="en-GB" sz="1600" dirty="0">
-                <a:solidFill>
-                  <a:srgbClr val="A41AE4"/>
-                </a:solidFill>
-              </a:rPr>
-              <a:t>. </a:t>
-            </a:r>
-          </a:p>
-          <a:p>
-            <a:endParaRPr lang="en-GB" sz="1600" dirty="0">
-              <a:solidFill>
-                <a:srgbClr val="A41AE4"/>
-              </a:solidFill>
-            </a:endParaRPr>
-          </a:p>
-          <a:p>
-            <a:r>
-              <a:rPr lang="en-GB" sz="1600" dirty="0">
-                <a:solidFill>
-                  <a:srgbClr val="A41AE4"/>
-                </a:solidFill>
-              </a:rPr>
-              <a:t>Behind the scenes, there is also the “Structure matrix” which contains the correlations </a:t>
-            </a:r>
-            <a:r>
-              <a:rPr lang="en-GB" sz="1600" dirty="0" err="1">
-                <a:solidFill>
-                  <a:srgbClr val="A41AE4"/>
-                </a:solidFill>
-                <a:latin typeface="Courier New" panose="02070309020205020404" pitchFamily="49" charset="0"/>
-                <a:cs typeface="Courier New" panose="02070309020205020404" pitchFamily="49" charset="0"/>
-              </a:rPr>
-              <a:t>cor</a:t>
-            </a:r>
-            <a:r>
-              <a:rPr lang="en-GB" sz="1600" dirty="0">
-                <a:solidFill>
-                  <a:srgbClr val="A41AE4"/>
-                </a:solidFill>
-                <a:latin typeface="Courier New" panose="02070309020205020404" pitchFamily="49" charset="0"/>
-                <a:cs typeface="Courier New" panose="02070309020205020404" pitchFamily="49" charset="0"/>
-              </a:rPr>
-              <a:t>(item, factor1) </a:t>
-            </a:r>
-            <a:r>
-              <a:rPr lang="en-GB" sz="1600" dirty="0">
-                <a:solidFill>
-                  <a:srgbClr val="A41AE4"/>
-                </a:solidFill>
-              </a:rPr>
-              <a:t>and </a:t>
-            </a:r>
-            <a:r>
-              <a:rPr lang="en-GB" sz="1600" dirty="0" err="1">
-                <a:solidFill>
-                  <a:srgbClr val="A41AE4"/>
-                </a:solidFill>
-                <a:latin typeface="Courier New" panose="02070309020205020404" pitchFamily="49" charset="0"/>
-                <a:cs typeface="Courier New" panose="02070309020205020404" pitchFamily="49" charset="0"/>
-              </a:rPr>
-              <a:t>cor</a:t>
-            </a:r>
-            <a:r>
-              <a:rPr lang="en-GB" sz="1600" dirty="0">
-                <a:solidFill>
-                  <a:srgbClr val="A41AE4"/>
-                </a:solidFill>
-                <a:latin typeface="Courier New" panose="02070309020205020404" pitchFamily="49" charset="0"/>
-                <a:cs typeface="Courier New" panose="02070309020205020404" pitchFamily="49" charset="0"/>
-              </a:rPr>
-              <a:t>(item, factor2)</a:t>
-            </a:r>
-            <a:r>
-              <a:rPr lang="en-GB" sz="1600" dirty="0">
-                <a:solidFill>
-                  <a:srgbClr val="A41AE4"/>
-                </a:solidFill>
-              </a:rPr>
-              <a:t>. </a:t>
-            </a:r>
-          </a:p>
-          <a:p>
-            <a:endParaRPr lang="en-GB" sz="1600" dirty="0">
-              <a:solidFill>
-                <a:srgbClr val="A41AE4"/>
-              </a:solidFill>
-            </a:endParaRPr>
-          </a:p>
-          <a:p>
-            <a:r>
-              <a:rPr lang="en-GB" sz="1600" dirty="0">
-                <a:solidFill>
-                  <a:srgbClr val="A41AE4"/>
-                </a:solidFill>
-              </a:rPr>
-              <a:t>If the factors are </a:t>
-            </a:r>
-            <a:r>
-              <a:rPr lang="en-GB" sz="1600" b="1" dirty="0">
-                <a:solidFill>
-                  <a:srgbClr val="A41AE4"/>
-                </a:solidFill>
-              </a:rPr>
-              <a:t>not</a:t>
-            </a:r>
-            <a:r>
-              <a:rPr lang="en-GB" sz="1600" dirty="0">
-                <a:solidFill>
-                  <a:srgbClr val="A41AE4"/>
-                </a:solidFill>
-              </a:rPr>
-              <a:t> correlated (by definition they are uncorrelated when no rotation or an orthogonal rotation is used), then pattern matrix and structure matrix are identical. </a:t>
+            <a:pPr algn="r"/>
+            <a:r>
+              <a:rPr lang="en-GB" sz="1400" dirty="0"/>
+              <a:t>MR2</a:t>
             </a:r>
           </a:p>
         </p:txBody>
       </p:sp>
       <p:sp>
         <p:nvSpPr>
-          <p:cNvPr id="20" name="Oval 19">
-            <a:extLst>
-              <a:ext uri="{FF2B5EF4-FFF2-40B4-BE49-F238E27FC236}">
-                <a16:creationId xmlns:a16="http://schemas.microsoft.com/office/drawing/2014/main" id="{310CBDB5-C19F-4DD8-8DAB-943D110523F4}"/>
+          <p:cNvPr id="6" name="Oval 5">
+            <a:extLst>
+              <a:ext uri="{FF2B5EF4-FFF2-40B4-BE49-F238E27FC236}">
+                <a16:creationId xmlns:a16="http://schemas.microsoft.com/office/drawing/2014/main" id="{DA2AF384-7889-E43E-9A8A-C2BD9C3AFE76}"/>
               </a:ext>
             </a:extLst>
           </p:cNvPr>
@@ -14065,7 +14365,7 @@
         </p:nvSpPr>
         <p:spPr>
           <a:xfrm>
-            <a:off x="4610242" y="4290527"/>
+            <a:off x="5120038" y="4539276"/>
             <a:ext cx="1100667" cy="1077218"/>
           </a:xfrm>
           <a:prstGeom prst="ellipse">
@@ -14098,13 +14398,14 @@
           <a:bodyPr rtlCol="0" anchor="ctr"/>
           <a:lstStyle/>
           <a:p>
+            <a:pPr algn="ctr"/>
             <a:r>
               <a:rPr lang="en-GB" sz="1400" dirty="0">
                 <a:solidFill>
                   <a:schemeClr val="tx1"/>
                 </a:solidFill>
               </a:rPr>
-              <a:t>Q10               </a:t>
+              <a:t>       </a:t>
             </a:r>
           </a:p>
           <a:p>
@@ -14123,65 +14424,6 @@
               </a:solidFill>
             </a:endParaRPr>
           </a:p>
-        </p:txBody>
-      </p:sp>
-      <p:sp>
-        <p:nvSpPr>
-          <p:cNvPr id="21" name="Oval 20">
-            <a:extLst>
-              <a:ext uri="{FF2B5EF4-FFF2-40B4-BE49-F238E27FC236}">
-                <a16:creationId xmlns:a16="http://schemas.microsoft.com/office/drawing/2014/main" id="{8384E7B2-ECB0-456D-987C-BA9B4C640248}"/>
-              </a:ext>
-            </a:extLst>
-          </p:cNvPr>
-          <p:cNvSpPr/>
-          <p:nvPr/>
-        </p:nvSpPr>
-        <p:spPr>
-          <a:xfrm>
-            <a:off x="5124270" y="4506715"/>
-            <a:ext cx="1100667" cy="1077218"/>
-          </a:xfrm>
-          <a:prstGeom prst="ellipse">
-            <a:avLst/>
-          </a:prstGeom>
-          <a:noFill/>
-          <a:ln>
-            <a:solidFill>
-              <a:schemeClr val="tx1"/>
-            </a:solidFill>
-          </a:ln>
-        </p:spPr>
-        <p:style>
-          <a:lnRef idx="2">
-            <a:schemeClr val="accent1">
-              <a:shade val="50000"/>
-            </a:schemeClr>
-          </a:lnRef>
-          <a:fillRef idx="1">
-            <a:schemeClr val="accent1"/>
-          </a:fillRef>
-          <a:effectRef idx="0">
-            <a:schemeClr val="accent1"/>
-          </a:effectRef>
-          <a:fontRef idx="minor">
-            <a:schemeClr val="lt1"/>
-          </a:fontRef>
-        </p:style>
-        <p:txBody>
-          <a:bodyPr rtlCol="0" anchor="ctr"/>
-          <a:lstStyle/>
-          <a:p>
-            <a:pPr algn="ctr"/>
-            <a:r>
-              <a:rPr lang="en-GB" sz="1400" dirty="0">
-                <a:solidFill>
-                  <a:schemeClr val="tx1"/>
-                </a:solidFill>
-              </a:rPr>
-              <a:t>       </a:t>
-            </a:r>
-          </a:p>
           <a:p>
             <a:pPr algn="ctr"/>
             <a:endParaRPr lang="en-GB" sz="1400" dirty="0">
@@ -14189,257 +14431,6 @@
                 <a:schemeClr val="tx1"/>
               </a:solidFill>
             </a:endParaRPr>
-          </a:p>
-          <a:p>
-            <a:pPr algn="ctr"/>
-            <a:endParaRPr lang="en-GB" sz="1400" dirty="0">
-              <a:solidFill>
-                <a:schemeClr val="tx1"/>
-              </a:solidFill>
-            </a:endParaRPr>
-          </a:p>
-          <a:p>
-            <a:pPr algn="ctr"/>
-            <a:endParaRPr lang="en-GB" sz="1400" dirty="0">
-              <a:solidFill>
-                <a:schemeClr val="tx1"/>
-              </a:solidFill>
-            </a:endParaRPr>
-          </a:p>
-        </p:txBody>
-      </p:sp>
-      <p:sp>
-        <p:nvSpPr>
-          <p:cNvPr id="28" name="TextBox 27">
-            <a:extLst>
-              <a:ext uri="{FF2B5EF4-FFF2-40B4-BE49-F238E27FC236}">
-                <a16:creationId xmlns:a16="http://schemas.microsoft.com/office/drawing/2014/main" id="{0B445740-202F-47B5-9B9B-E1A66179E9F8}"/>
-              </a:ext>
-            </a:extLst>
-          </p:cNvPr>
-          <p:cNvSpPr txBox="1"/>
-          <p:nvPr/>
-        </p:nvSpPr>
-        <p:spPr>
-          <a:xfrm>
-            <a:off x="5554978" y="4867628"/>
-            <a:ext cx="690034" cy="307777"/>
-          </a:xfrm>
-          <a:prstGeom prst="rect">
-            <a:avLst/>
-          </a:prstGeom>
-          <a:noFill/>
-        </p:spPr>
-        <p:txBody>
-          <a:bodyPr wrap="square">
-            <a:spAutoFit/>
-          </a:bodyPr>
-          <a:lstStyle/>
-          <a:p>
-            <a:pPr algn="r"/>
-            <a:r>
-              <a:rPr lang="en-GB" sz="1400" dirty="0"/>
-              <a:t>ML2</a:t>
-            </a:r>
-          </a:p>
-        </p:txBody>
-      </p:sp>
-      <p:sp>
-        <p:nvSpPr>
-          <p:cNvPr id="45" name="Oval 44">
-            <a:extLst>
-              <a:ext uri="{FF2B5EF4-FFF2-40B4-BE49-F238E27FC236}">
-                <a16:creationId xmlns:a16="http://schemas.microsoft.com/office/drawing/2014/main" id="{0AB6BDCA-1687-4B9E-B338-D36D15256A4E}"/>
-              </a:ext>
-            </a:extLst>
-          </p:cNvPr>
-          <p:cNvSpPr/>
-          <p:nvPr/>
-        </p:nvSpPr>
-        <p:spPr>
-          <a:xfrm>
-            <a:off x="1781516" y="4290527"/>
-            <a:ext cx="1100667" cy="1077218"/>
-          </a:xfrm>
-          <a:prstGeom prst="ellipse">
-            <a:avLst/>
-          </a:prstGeom>
-          <a:noFill/>
-          <a:ln>
-            <a:solidFill>
-              <a:schemeClr val="tx1"/>
-            </a:solidFill>
-          </a:ln>
-        </p:spPr>
-        <p:style>
-          <a:lnRef idx="2">
-            <a:schemeClr val="accent1">
-              <a:shade val="50000"/>
-            </a:schemeClr>
-          </a:lnRef>
-          <a:fillRef idx="1">
-            <a:schemeClr val="accent1"/>
-          </a:fillRef>
-          <a:effectRef idx="0">
-            <a:schemeClr val="accent1"/>
-          </a:effectRef>
-          <a:fontRef idx="minor">
-            <a:schemeClr val="lt1"/>
-          </a:fontRef>
-        </p:style>
-        <p:txBody>
-          <a:bodyPr rtlCol="0" anchor="ctr"/>
-          <a:lstStyle/>
-          <a:p>
-            <a:r>
-              <a:rPr lang="en-GB" sz="1400" dirty="0">
-                <a:solidFill>
-                  <a:schemeClr val="tx1"/>
-                </a:solidFill>
-              </a:rPr>
-              <a:t>Q10               </a:t>
-            </a:r>
-          </a:p>
-          <a:p>
-            <a:pPr algn="ctr"/>
-            <a:endParaRPr lang="en-GB" sz="1400" dirty="0">
-              <a:solidFill>
-                <a:schemeClr val="tx1"/>
-              </a:solidFill>
-            </a:endParaRPr>
-          </a:p>
-          <a:p>
-            <a:pPr algn="ctr"/>
-            <a:endParaRPr lang="en-GB" sz="1400" dirty="0">
-              <a:solidFill>
-                <a:schemeClr val="tx1"/>
-              </a:solidFill>
-            </a:endParaRPr>
-          </a:p>
-        </p:txBody>
-      </p:sp>
-      <p:sp>
-        <p:nvSpPr>
-          <p:cNvPr id="47" name="Oval 46">
-            <a:extLst>
-              <a:ext uri="{FF2B5EF4-FFF2-40B4-BE49-F238E27FC236}">
-                <a16:creationId xmlns:a16="http://schemas.microsoft.com/office/drawing/2014/main" id="{67092F04-50D0-4C4A-AD62-DD1E545AE9DF}"/>
-              </a:ext>
-            </a:extLst>
-          </p:cNvPr>
-          <p:cNvSpPr/>
-          <p:nvPr/>
-        </p:nvSpPr>
-        <p:spPr>
-          <a:xfrm>
-            <a:off x="2186307" y="5169127"/>
-            <a:ext cx="1100667" cy="1077218"/>
-          </a:xfrm>
-          <a:prstGeom prst="ellipse">
-            <a:avLst/>
-          </a:prstGeom>
-          <a:noFill/>
-          <a:ln>
-            <a:solidFill>
-              <a:schemeClr val="tx1"/>
-            </a:solidFill>
-          </a:ln>
-        </p:spPr>
-        <p:style>
-          <a:lnRef idx="2">
-            <a:schemeClr val="accent1">
-              <a:shade val="50000"/>
-            </a:schemeClr>
-          </a:lnRef>
-          <a:fillRef idx="1">
-            <a:schemeClr val="accent1"/>
-          </a:fillRef>
-          <a:effectRef idx="0">
-            <a:schemeClr val="accent1"/>
-          </a:effectRef>
-          <a:fontRef idx="minor">
-            <a:schemeClr val="lt1"/>
-          </a:fontRef>
-        </p:style>
-        <p:txBody>
-          <a:bodyPr rtlCol="0" anchor="ctr"/>
-          <a:lstStyle/>
-          <a:p>
-            <a:pPr algn="ctr"/>
-            <a:endParaRPr lang="en-GB" sz="1400" dirty="0">
-              <a:solidFill>
-                <a:schemeClr val="tx1"/>
-              </a:solidFill>
-            </a:endParaRPr>
-          </a:p>
-          <a:p>
-            <a:pPr algn="ctr"/>
-            <a:endParaRPr lang="en-GB" sz="1400" dirty="0">
-              <a:solidFill>
-                <a:schemeClr val="tx1"/>
-              </a:solidFill>
-            </a:endParaRPr>
-          </a:p>
-          <a:p>
-            <a:pPr algn="ctr"/>
-            <a:endParaRPr lang="en-GB" sz="1400" dirty="0">
-              <a:solidFill>
-                <a:schemeClr val="tx1"/>
-              </a:solidFill>
-            </a:endParaRPr>
-          </a:p>
-          <a:p>
-            <a:pPr algn="ctr"/>
-            <a:r>
-              <a:rPr lang="en-GB" sz="1400" dirty="0">
-                <a:solidFill>
-                  <a:schemeClr val="tx1"/>
-                </a:solidFill>
-              </a:rPr>
-              <a:t>ML1</a:t>
-            </a:r>
-          </a:p>
-        </p:txBody>
-      </p:sp>
-      <p:sp>
-        <p:nvSpPr>
-          <p:cNvPr id="48" name="TextBox 47">
-            <a:extLst>
-              <a:ext uri="{FF2B5EF4-FFF2-40B4-BE49-F238E27FC236}">
-                <a16:creationId xmlns:a16="http://schemas.microsoft.com/office/drawing/2014/main" id="{09FE0C98-AE7B-4971-8B4E-CC57DDB1309A}"/>
-              </a:ext>
-            </a:extLst>
-          </p:cNvPr>
-          <p:cNvSpPr txBox="1"/>
-          <p:nvPr/>
-        </p:nvSpPr>
-        <p:spPr>
-          <a:xfrm>
-            <a:off x="2726252" y="4867628"/>
-            <a:ext cx="690034" cy="307777"/>
-          </a:xfrm>
-          <a:prstGeom prst="rect">
-            <a:avLst/>
-          </a:prstGeom>
-          <a:noFill/>
-        </p:spPr>
-        <p:txBody>
-          <a:bodyPr wrap="square">
-            <a:spAutoFit/>
-          </a:bodyPr>
-          <a:lstStyle/>
-          <a:p>
-            <a:pPr algn="r"/>
-            <a:r>
-              <a:rPr lang="en-GB" sz="1400" dirty="0">
-                <a:solidFill>
-                  <a:schemeClr val="bg1">
-                    <a:lumMod val="85000"/>
-                  </a:schemeClr>
-                </a:solidFill>
-              </a:rPr>
-              <a:t>ML2</a:t>
-            </a:r>
           </a:p>
         </p:txBody>
       </p:sp>
@@ -14475,10 +14466,10 @@
       </p:grpSpPr>
       <p:pic>
         <p:nvPicPr>
-          <p:cNvPr id="23" name="Picture 22">
-            <a:extLst>
-              <a:ext uri="{FF2B5EF4-FFF2-40B4-BE49-F238E27FC236}">
-                <a16:creationId xmlns:a16="http://schemas.microsoft.com/office/drawing/2014/main" id="{1896DCD2-1C3D-4A9B-98F6-225CEEB03BD5}"/>
+          <p:cNvPr id="3" name="Picture 2">
+            <a:extLst>
+              <a:ext uri="{FF2B5EF4-FFF2-40B4-BE49-F238E27FC236}">
+                <a16:creationId xmlns:a16="http://schemas.microsoft.com/office/drawing/2014/main" id="{523DB4F2-C964-A0A3-30A4-25C3689AF859}"/>
               </a:ext>
             </a:extLst>
           </p:cNvPr>
@@ -14495,8 +14486,8 @@
         </p:blipFill>
         <p:spPr>
           <a:xfrm>
-            <a:off x="3319104" y="635697"/>
-            <a:ext cx="8840434" cy="5925377"/>
+            <a:off x="3319712" y="636622"/>
+            <a:ext cx="9297698" cy="5944430"/>
           </a:xfrm>
           <a:prstGeom prst="rect">
             <a:avLst/>
@@ -14559,7 +14550,7 @@
                   <a:srgbClr val="A41AE4"/>
                 </a:solidFill>
               </a:rPr>
-              <a:t>e.g., 37% of the variance in Q10 is explained by the two factors</a:t>
+              <a:t>e.g., 32% of the variance in Q10 is explained by the two factors</a:t>
             </a:r>
           </a:p>
           <a:p>
@@ -15224,10 +15215,10 @@
       </p:grpSpPr>
       <p:pic>
         <p:nvPicPr>
-          <p:cNvPr id="23" name="Picture 22">
-            <a:extLst>
-              <a:ext uri="{FF2B5EF4-FFF2-40B4-BE49-F238E27FC236}">
-                <a16:creationId xmlns:a16="http://schemas.microsoft.com/office/drawing/2014/main" id="{137788C3-C6EC-4987-B566-1DAB7E82A526}"/>
+          <p:cNvPr id="2" name="Picture 1">
+            <a:extLst>
+              <a:ext uri="{FF2B5EF4-FFF2-40B4-BE49-F238E27FC236}">
+                <a16:creationId xmlns:a16="http://schemas.microsoft.com/office/drawing/2014/main" id="{B410CC5B-689E-E493-100D-483F3885B348}"/>
               </a:ext>
             </a:extLst>
           </p:cNvPr>
@@ -15244,8 +15235,8 @@
         </p:blipFill>
         <p:spPr>
           <a:xfrm>
-            <a:off x="3319104" y="635697"/>
-            <a:ext cx="8840434" cy="5925377"/>
+            <a:off x="3319712" y="636622"/>
+            <a:ext cx="9297698" cy="5944430"/>
           </a:xfrm>
           <a:prstGeom prst="rect">
             <a:avLst/>
@@ -15324,7 +15315,7 @@
                   <a:srgbClr val="A41AE4"/>
                 </a:solidFill>
               </a:rPr>
-              <a:t>e.g., 63% of the variance in Q10 is left unexplained</a:t>
+              <a:t>e.g., 68% of the variance in Q10 is left unexplained</a:t>
             </a:r>
           </a:p>
         </p:txBody>
@@ -15935,10 +15926,10 @@
       </p:grpSpPr>
       <p:pic>
         <p:nvPicPr>
-          <p:cNvPr id="22" name="Picture 21">
-            <a:extLst>
-              <a:ext uri="{FF2B5EF4-FFF2-40B4-BE49-F238E27FC236}">
-                <a16:creationId xmlns:a16="http://schemas.microsoft.com/office/drawing/2014/main" id="{6BCD2040-E854-40E8-96F3-B974EF2BCC5F}"/>
+          <p:cNvPr id="2" name="Picture 1">
+            <a:extLst>
+              <a:ext uri="{FF2B5EF4-FFF2-40B4-BE49-F238E27FC236}">
+                <a16:creationId xmlns:a16="http://schemas.microsoft.com/office/drawing/2014/main" id="{A817443F-6C0D-E353-123D-B7082316444B}"/>
               </a:ext>
             </a:extLst>
           </p:cNvPr>
@@ -15955,8 +15946,8 @@
         </p:blipFill>
         <p:spPr>
           <a:xfrm>
-            <a:off x="3319104" y="635697"/>
-            <a:ext cx="8840434" cy="5925377"/>
+            <a:off x="3319712" y="636622"/>
+            <a:ext cx="9297698" cy="5944430"/>
           </a:xfrm>
           <a:prstGeom prst="rect">
             <a:avLst/>
@@ -16635,10 +16626,10 @@
       </p:grpSpPr>
       <p:pic>
         <p:nvPicPr>
-          <p:cNvPr id="25" name="Picture 24">
-            <a:extLst>
-              <a:ext uri="{FF2B5EF4-FFF2-40B4-BE49-F238E27FC236}">
-                <a16:creationId xmlns:a16="http://schemas.microsoft.com/office/drawing/2014/main" id="{912EBE48-8F44-4070-A8EF-54186DBBADE1}"/>
+          <p:cNvPr id="4" name="Picture 3">
+            <a:extLst>
+              <a:ext uri="{FF2B5EF4-FFF2-40B4-BE49-F238E27FC236}">
+                <a16:creationId xmlns:a16="http://schemas.microsoft.com/office/drawing/2014/main" id="{FEAEA21A-B849-265D-8EE3-6DE62BD8B63D}"/>
               </a:ext>
             </a:extLst>
           </p:cNvPr>
@@ -16655,8 +16646,8 @@
         </p:blipFill>
         <p:spPr>
           <a:xfrm>
-            <a:off x="3319104" y="635697"/>
-            <a:ext cx="8840434" cy="5925377"/>
+            <a:off x="3319712" y="636622"/>
+            <a:ext cx="9297698" cy="5944430"/>
           </a:xfrm>
           <a:prstGeom prst="rect">
             <a:avLst/>

</xml_diff>